<commit_message>
Rapport Boulanger 01.10-08.10 : stats média issues de l'export campagne du 09/10
Co-Authored-By: Claude Opus 5.5 <noreply@anthropic.com>
Claude-Session: https://claude.ai/code/session_018e7SCuQygFSJNrAfjS85j9
</commit_message>
<xml_diff>
--- a/rapports/In progress_20261009_Rapport_Boulanger_Hebdo_01.10-08.10.pptx
+++ b/rapports/In progress_20261009_Rapport_Boulanger_Hebdo_01.10-08.10.pptx
@@ -118,12 +118,12 @@
   <p:extLst>
     <p:ext uri="{521415D9-36F7-43E2-AB2F-B90AF26B5E84}">
       <p14:sectionLst xmlns:p14="http://schemas.microsoft.com/office/powerpoint/2010/main">
-        <p14:section name="Introduction" id="{3b92aa3d-9b67-ebbf-2d3a-54f6203f451b}">
+        <p14:section name="Introduction" id="{726c7d39-25ef-cda0-72a2-3e6521105287}">
           <p14:sldIdLst>
             <p14:sldId id="256"/>
           </p14:sldIdLst>
         </p14:section>
-        <p14:section name="Boulanger" id="{e38d4c9c-b20c-eb00-0e84-40e84230525e}">
+        <p14:section name="Boulanger" id="{e66bbf44-c82a-5fd6-9196-6278b7a29ad1}">
           <p14:sldIdLst>
             <p14:sldId id="257"/>
             <p14:sldId id="258"/>
@@ -134,7 +134,7 @@
             <p14:sldId id="263"/>
           </p14:sldIdLst>
         </p14:section>
-        <p14:section name="Pistes de reco" id="{116b9b20-ef86-2434-ebc1-ac872c77effd}">
+        <p14:section name="Pistes de reco" id="{5221ac71-fe45-bc77-d4fd-e9d283f0ac4e}">
           <p14:sldIdLst>
             <p14:sldId id="264"/>
             <p14:sldId id="265"/>
@@ -4831,7 +4831,7 @@
                   <a:srgbClr val="1B2238"/>
                 </a:solidFill>
               </a:rPr>
-              <a:t>Share of Voice GEA en recul de 2,8 pts, à 20,2 %.</a:t>
+              <a:t>CTR en recul de 0,16 pt à 0,49 %, CPC en hausse de 26,6 % à 0,37 €.</a:t>
             </a:r>
             <a:endParaRPr lang="en-US" sz="1600" dirty="0"/>
           </a:p>
@@ -6319,7 +6319,7 @@
                   <a:schemeClr val="tx1"/>
                 </a:solidFill>
               </a:rPr>
-              <a:t>Boulanger gagne +2,5 pts de recommandations spontanées des IA</a:t>
+              <a:t>Plus de diffusion, moins de clics, des clics plus chers</a:t>
             </a:r>
             <a:endParaRPr lang="en-US" sz="3000" dirty="0"/>
           </a:p>
@@ -6370,7 +6370,7 @@
         <p:spPr>
           <a:xfrm>
             <a:off x="548640" y="1737360"/>
-            <a:ext cx="5486400" cy="274320"/>
+            <a:ext cx="10972800" cy="274320"/>
           </a:xfrm>
           <a:prstGeom prst="rect">
             <a:avLst/>
@@ -6391,7 +6391,7 @@
                   <a:srgbClr val="E8601C"/>
                 </a:solidFill>
               </a:rPr>
-              <a:t>PERFORMANCE MÉDIA</a:t>
+              <a:t>PERFORMANCE MÉDIA · BUDGET CONSOMMÉ 7 279,90 € sur 30 000 € · 24 %</a:t>
             </a:r>
             <a:endParaRPr lang="en-US" sz="1200" dirty="0"/>
           </a:p>
@@ -6406,491 +6406,11 @@
         <p:spPr>
           <a:xfrm>
             <a:off x="548640" y="2057400"/>
-            <a:ext cx="3520440" cy="603504"/>
+            <a:ext cx="1755648" cy="1371600"/>
           </a:xfrm>
           <a:prstGeom prst="roundRect">
             <a:avLst>
-              <a:gd name="adj" fmla="val 12121"/>
-            </a:avLst>
-          </a:prstGeom>
-          <a:solidFill>
-            <a:srgbClr val="F2F4F8"/>
-          </a:solidFill>
-          <a:ln w="12700">
-            <a:solidFill>
-              <a:srgbClr val="D9DDE5"/>
-            </a:solidFill>
-            <a:prstDash val="dash"/>
-          </a:ln>
-        </p:spPr>
-      </p:sp>
-      <p:sp>
-        <p:nvSpPr>
-          <p:cNvPr id="7" name="Text 5"/>
-          <p:cNvSpPr txBox="1"/>
-          <p:nvPr/>
-        </p:nvSpPr>
-        <p:spPr>
-          <a:xfrm>
-            <a:off x="731520" y="2057400"/>
-            <a:ext cx="3200400" cy="603504"/>
-          </a:xfrm>
-          <a:prstGeom prst="rect">
-            <a:avLst/>
-          </a:prstGeom>
-          <a:noFill/>
-          <a:ln/>
-        </p:spPr>
-        <p:txBody>
-          <a:bodyPr wrap="square" lIns="0" tIns="0" rIns="0" bIns="0" rtlCol="0" anchor="ctr"/>
-          <a:lstStyle/>
-          <a:p>
-            <a:pPr indent="0" marL="0">
-              <a:buNone/>
-            </a:pPr>
-            <a:r>
-              <a:rPr lang="en-US" sz="1100" b="1" dirty="0">
-                <a:solidFill>
-                  <a:srgbClr val="5A6275"/>
-                </a:solidFill>
-              </a:rPr>
-              <a:t>Budget consommé   </a:t>
-            </a:r>
-            <a:pPr indent="0" marL="0">
-              <a:buNone/>
-            </a:pPr>
-            <a:r>
-              <a:rPr lang="en-US" sz="1400" b="1" dirty="0">
-                <a:solidFill>
-                  <a:srgbClr val="C8372D"/>
-                </a:solidFill>
-              </a:rPr>
-              <a:t>À compléter</a:t>
-            </a:r>
-            <a:endParaRPr lang="en-US" sz="1100" dirty="0"/>
-          </a:p>
-        </p:txBody>
-      </p:sp>
-      <p:sp>
-        <p:nvSpPr>
-          <p:cNvPr id="8" name="Shape 6"/>
-          <p:cNvSpPr/>
-          <p:nvPr/>
-        </p:nvSpPr>
-        <p:spPr>
-          <a:xfrm>
-            <a:off x="4315968" y="2057400"/>
-            <a:ext cx="3520440" cy="603504"/>
-          </a:xfrm>
-          <a:prstGeom prst="roundRect">
-            <a:avLst>
-              <a:gd name="adj" fmla="val 12121"/>
-            </a:avLst>
-          </a:prstGeom>
-          <a:solidFill>
-            <a:srgbClr val="F2F4F8"/>
-          </a:solidFill>
-          <a:ln w="12700">
-            <a:solidFill>
-              <a:srgbClr val="D9DDE5"/>
-            </a:solidFill>
-            <a:prstDash val="dash"/>
-          </a:ln>
-        </p:spPr>
-      </p:sp>
-      <p:sp>
-        <p:nvSpPr>
-          <p:cNvPr id="9" name="Text 7"/>
-          <p:cNvSpPr txBox="1"/>
-          <p:nvPr/>
-        </p:nvSpPr>
-        <p:spPr>
-          <a:xfrm>
-            <a:off x="4498848" y="2057400"/>
-            <a:ext cx="3200400" cy="603504"/>
-          </a:xfrm>
-          <a:prstGeom prst="rect">
-            <a:avLst/>
-          </a:prstGeom>
-          <a:noFill/>
-          <a:ln/>
-        </p:spPr>
-        <p:txBody>
-          <a:bodyPr wrap="square" lIns="0" tIns="0" rIns="0" bIns="0" rtlCol="0" anchor="ctr"/>
-          <a:lstStyle/>
-          <a:p>
-            <a:pPr indent="0" marL="0">
-              <a:buNone/>
-            </a:pPr>
-            <a:r>
-              <a:rPr lang="en-US" sz="1100" b="1" dirty="0">
-                <a:solidFill>
-                  <a:srgbClr val="5A6275"/>
-                </a:solidFill>
-              </a:rPr>
-              <a:t>Mentions conversationnelles   </a:t>
-            </a:r>
-            <a:pPr indent="0" marL="0">
-              <a:buNone/>
-            </a:pPr>
-            <a:r>
-              <a:rPr lang="en-US" sz="1400" b="1" dirty="0">
-                <a:solidFill>
-                  <a:srgbClr val="C8372D"/>
-                </a:solidFill>
-              </a:rPr>
-              <a:t>À compléter</a:t>
-            </a:r>
-            <a:endParaRPr lang="en-US" sz="1100" dirty="0"/>
-          </a:p>
-        </p:txBody>
-      </p:sp>
-      <p:sp>
-        <p:nvSpPr>
-          <p:cNvPr id="10" name="Shape 8"/>
-          <p:cNvSpPr/>
-          <p:nvPr/>
-        </p:nvSpPr>
-        <p:spPr>
-          <a:xfrm>
-            <a:off x="8083296" y="2057400"/>
-            <a:ext cx="3520440" cy="603504"/>
-          </a:xfrm>
-          <a:prstGeom prst="roundRect">
-            <a:avLst>
-              <a:gd name="adj" fmla="val 12121"/>
-            </a:avLst>
-          </a:prstGeom>
-          <a:solidFill>
-            <a:srgbClr val="F2F4F8"/>
-          </a:solidFill>
-          <a:ln w="12700">
-            <a:solidFill>
-              <a:srgbClr val="D9DDE5"/>
-            </a:solidFill>
-            <a:prstDash val="dash"/>
-          </a:ln>
-        </p:spPr>
-      </p:sp>
-      <p:sp>
-        <p:nvSpPr>
-          <p:cNvPr id="11" name="Text 9"/>
-          <p:cNvSpPr txBox="1"/>
-          <p:nvPr/>
-        </p:nvSpPr>
-        <p:spPr>
-          <a:xfrm>
-            <a:off x="8266176" y="2057400"/>
-            <a:ext cx="3200400" cy="603504"/>
-          </a:xfrm>
-          <a:prstGeom prst="rect">
-            <a:avLst/>
-          </a:prstGeom>
-          <a:noFill/>
-          <a:ln/>
-        </p:spPr>
-        <p:txBody>
-          <a:bodyPr wrap="square" lIns="0" tIns="0" rIns="0" bIns="0" rtlCol="0" anchor="ctr"/>
-          <a:lstStyle/>
-          <a:p>
-            <a:pPr indent="0" marL="0">
-              <a:buNone/>
-            </a:pPr>
-            <a:r>
-              <a:rPr lang="en-US" sz="1100" b="1" dirty="0">
-                <a:solidFill>
-                  <a:srgbClr val="5A6275"/>
-                </a:solidFill>
-              </a:rPr>
-              <a:t>Trafic LLM qualifié   </a:t>
-            </a:r>
-            <a:pPr indent="0" marL="0">
-              <a:buNone/>
-            </a:pPr>
-            <a:r>
-              <a:rPr lang="en-US" sz="1400" b="1" dirty="0">
-                <a:solidFill>
-                  <a:srgbClr val="C8372D"/>
-                </a:solidFill>
-              </a:rPr>
-              <a:t>À compléter</a:t>
-            </a:r>
-            <a:endParaRPr lang="en-US" sz="1100" dirty="0"/>
-          </a:p>
-        </p:txBody>
-      </p:sp>
-      <p:sp>
-        <p:nvSpPr>
-          <p:cNvPr id="12" name="Shape 10"/>
-          <p:cNvSpPr/>
-          <p:nvPr/>
-        </p:nvSpPr>
-        <p:spPr>
-          <a:xfrm>
-            <a:off x="548640" y="2770632"/>
-            <a:ext cx="3520440" cy="603504"/>
-          </a:xfrm>
-          <a:prstGeom prst="roundRect">
-            <a:avLst>
-              <a:gd name="adj" fmla="val 12121"/>
-            </a:avLst>
-          </a:prstGeom>
-          <a:solidFill>
-            <a:srgbClr val="F2F4F8"/>
-          </a:solidFill>
-          <a:ln w="12700">
-            <a:solidFill>
-              <a:srgbClr val="D9DDE5"/>
-            </a:solidFill>
-            <a:prstDash val="dash"/>
-          </a:ln>
-        </p:spPr>
-      </p:sp>
-      <p:sp>
-        <p:nvSpPr>
-          <p:cNvPr id="13" name="Text 11"/>
-          <p:cNvSpPr txBox="1"/>
-          <p:nvPr/>
-        </p:nvSpPr>
-        <p:spPr>
-          <a:xfrm>
-            <a:off x="731520" y="2770632"/>
-            <a:ext cx="3200400" cy="603504"/>
-          </a:xfrm>
-          <a:prstGeom prst="rect">
-            <a:avLst/>
-          </a:prstGeom>
-          <a:noFill/>
-          <a:ln/>
-        </p:spPr>
-        <p:txBody>
-          <a:bodyPr wrap="square" lIns="0" tIns="0" rIns="0" bIns="0" rtlCol="0" anchor="ctr"/>
-          <a:lstStyle/>
-          <a:p>
-            <a:pPr indent="0" marL="0">
-              <a:buNone/>
-            </a:pPr>
-            <a:r>
-              <a:rPr lang="en-US" sz="1100" b="1" dirty="0">
-                <a:solidFill>
-                  <a:srgbClr val="5A6275"/>
-                </a:solidFill>
-              </a:rPr>
-              <a:t>CTR   </a:t>
-            </a:r>
-            <a:pPr indent="0" marL="0">
-              <a:buNone/>
-            </a:pPr>
-            <a:r>
-              <a:rPr lang="en-US" sz="1400" b="1" dirty="0">
-                <a:solidFill>
-                  <a:srgbClr val="C8372D"/>
-                </a:solidFill>
-              </a:rPr>
-              <a:t>À compléter</a:t>
-            </a:r>
-            <a:endParaRPr lang="en-US" sz="1100" dirty="0"/>
-          </a:p>
-        </p:txBody>
-      </p:sp>
-      <p:sp>
-        <p:nvSpPr>
-          <p:cNvPr id="14" name="Shape 12"/>
-          <p:cNvSpPr/>
-          <p:nvPr/>
-        </p:nvSpPr>
-        <p:spPr>
-          <a:xfrm>
-            <a:off x="4315968" y="2770632"/>
-            <a:ext cx="3520440" cy="603504"/>
-          </a:xfrm>
-          <a:prstGeom prst="roundRect">
-            <a:avLst>
-              <a:gd name="adj" fmla="val 12121"/>
-            </a:avLst>
-          </a:prstGeom>
-          <a:solidFill>
-            <a:srgbClr val="F2F4F8"/>
-          </a:solidFill>
-          <a:ln w="12700">
-            <a:solidFill>
-              <a:srgbClr val="D9DDE5"/>
-            </a:solidFill>
-            <a:prstDash val="dash"/>
-          </a:ln>
-        </p:spPr>
-      </p:sp>
-      <p:sp>
-        <p:nvSpPr>
-          <p:cNvPr id="15" name="Text 13"/>
-          <p:cNvSpPr txBox="1"/>
-          <p:nvPr/>
-        </p:nvSpPr>
-        <p:spPr>
-          <a:xfrm>
-            <a:off x="4498848" y="2770632"/>
-            <a:ext cx="3200400" cy="603504"/>
-          </a:xfrm>
-          <a:prstGeom prst="rect">
-            <a:avLst/>
-          </a:prstGeom>
-          <a:noFill/>
-          <a:ln/>
-        </p:spPr>
-        <p:txBody>
-          <a:bodyPr wrap="square" lIns="0" tIns="0" rIns="0" bIns="0" rtlCol="0" anchor="ctr"/>
-          <a:lstStyle/>
-          <a:p>
-            <a:pPr indent="0" marL="0">
-              <a:buNone/>
-            </a:pPr>
-            <a:r>
-              <a:rPr lang="en-US" sz="1100" b="1" dirty="0">
-                <a:solidFill>
-                  <a:srgbClr val="5A6275"/>
-                </a:solidFill>
-              </a:rPr>
-              <a:t>CPC moyen   </a:t>
-            </a:r>
-            <a:pPr indent="0" marL="0">
-              <a:buNone/>
-            </a:pPr>
-            <a:r>
-              <a:rPr lang="en-US" sz="1400" b="1" dirty="0">
-                <a:solidFill>
-                  <a:srgbClr val="C8372D"/>
-                </a:solidFill>
-              </a:rPr>
-              <a:t>À compléter</a:t>
-            </a:r>
-            <a:endParaRPr lang="en-US" sz="1100" dirty="0"/>
-          </a:p>
-        </p:txBody>
-      </p:sp>
-      <p:sp>
-        <p:nvSpPr>
-          <p:cNvPr id="16" name="Shape 14"/>
-          <p:cNvSpPr/>
-          <p:nvPr/>
-        </p:nvSpPr>
-        <p:spPr>
-          <a:xfrm>
-            <a:off x="8083296" y="2770632"/>
-            <a:ext cx="3520440" cy="603504"/>
-          </a:xfrm>
-          <a:prstGeom prst="roundRect">
-            <a:avLst>
-              <a:gd name="adj" fmla="val 12121"/>
-            </a:avLst>
-          </a:prstGeom>
-          <a:solidFill>
-            <a:srgbClr val="F2F4F8"/>
-          </a:solidFill>
-          <a:ln w="12700">
-            <a:solidFill>
-              <a:srgbClr val="D9DDE5"/>
-            </a:solidFill>
-            <a:prstDash val="dash"/>
-          </a:ln>
-        </p:spPr>
-      </p:sp>
-      <p:sp>
-        <p:nvSpPr>
-          <p:cNvPr id="17" name="Text 15"/>
-          <p:cNvSpPr txBox="1"/>
-          <p:nvPr/>
-        </p:nvSpPr>
-        <p:spPr>
-          <a:xfrm>
-            <a:off x="8266176" y="2770632"/>
-            <a:ext cx="3200400" cy="603504"/>
-          </a:xfrm>
-          <a:prstGeom prst="rect">
-            <a:avLst/>
-          </a:prstGeom>
-          <a:noFill/>
-          <a:ln/>
-        </p:spPr>
-        <p:txBody>
-          <a:bodyPr wrap="square" lIns="0" tIns="0" rIns="0" bIns="0" rtlCol="0" anchor="ctr"/>
-          <a:lstStyle/>
-          <a:p>
-            <a:pPr indent="0" marL="0">
-              <a:buNone/>
-            </a:pPr>
-            <a:r>
-              <a:rPr lang="en-US" sz="1100" b="1" dirty="0">
-                <a:solidFill>
-                  <a:srgbClr val="5A6275"/>
-                </a:solidFill>
-              </a:rPr>
-              <a:t>Conversions last click   </a:t>
-            </a:r>
-            <a:pPr indent="0" marL="0">
-              <a:buNone/>
-            </a:pPr>
-            <a:r>
-              <a:rPr lang="en-US" sz="1400" b="1" dirty="0">
-                <a:solidFill>
-                  <a:srgbClr val="C8372D"/>
-                </a:solidFill>
-              </a:rPr>
-              <a:t>n. d.</a:t>
-            </a:r>
-            <a:endParaRPr lang="en-US" sz="1100" dirty="0"/>
-          </a:p>
-        </p:txBody>
-      </p:sp>
-      <p:sp>
-        <p:nvSpPr>
-          <p:cNvPr id="18" name="Text 16"/>
-          <p:cNvSpPr txBox="1"/>
-          <p:nvPr/>
-        </p:nvSpPr>
-        <p:spPr>
-          <a:xfrm>
-            <a:off x="548640" y="3566160"/>
-            <a:ext cx="5486400" cy="274320"/>
-          </a:xfrm>
-          <a:prstGeom prst="rect">
-            <a:avLst/>
-          </a:prstGeom>
-          <a:noFill/>
-          <a:ln/>
-        </p:spPr>
-        <p:txBody>
-          <a:bodyPr wrap="square" lIns="0" tIns="0" rIns="0" bIns="0" rtlCol="0" anchor="ctr"/>
-          <a:lstStyle/>
-          <a:p>
-            <a:pPr indent="0" marL="0">
-              <a:buNone/>
-            </a:pPr>
-            <a:r>
-              <a:rPr lang="en-US" sz="1200" b="1" dirty="0">
-                <a:solidFill>
-                  <a:srgbClr val="E8601C"/>
-                </a:solidFill>
-              </a:rPr>
-              <a:t>VISIBILITÉ DANS LES RÉPONSES DE L'IA</a:t>
-            </a:r>
-            <a:endParaRPr lang="en-US" sz="1200" dirty="0"/>
-          </a:p>
-        </p:txBody>
-      </p:sp>
-      <p:sp>
-        <p:nvSpPr>
-          <p:cNvPr id="19" name="Shape 17"/>
-          <p:cNvSpPr/>
-          <p:nvPr/>
-        </p:nvSpPr>
-        <p:spPr>
-          <a:xfrm>
-            <a:off x="548640" y="3886200"/>
-            <a:ext cx="2651760" cy="1417320"/>
-          </a:xfrm>
-          <a:prstGeom prst="roundRect">
-            <a:avLst>
-              <a:gd name="adj" fmla="val 6452"/>
+              <a:gd name="adj" fmla="val 5333"/>
             </a:avLst>
           </a:prstGeom>
           <a:solidFill>
@@ -6906,14 +6426,14 @@
       </p:sp>
       <p:sp>
         <p:nvSpPr>
-          <p:cNvPr id="20" name="Text 18"/>
+          <p:cNvPr id="7" name="Text 5"/>
           <p:cNvSpPr txBox="1"/>
           <p:nvPr/>
         </p:nvSpPr>
         <p:spPr>
           <a:xfrm>
-            <a:off x="731520" y="3977640"/>
-            <a:ext cx="2286000" cy="274320"/>
+            <a:off x="658368" y="2130552"/>
+            <a:ext cx="1536192" cy="329184"/>
           </a:xfrm>
           <a:prstGeom prst="rect">
             <a:avLst/>
@@ -6922,34 +6442,34 @@
           <a:ln/>
         </p:spPr>
         <p:txBody>
-          <a:bodyPr wrap="square" lIns="0" tIns="0" rIns="0" bIns="0" rtlCol="0" anchor="ctr"/>
+          <a:bodyPr wrap="square" lIns="0" tIns="0" rIns="0" bIns="0" rtlCol="0" anchor="t"/>
           <a:lstStyle/>
           <a:p>
             <a:pPr indent="0" marL="0">
               <a:buNone/>
             </a:pPr>
             <a:r>
-              <a:rPr lang="en-US" sz="1100" b="1" dirty="0">
+              <a:rPr lang="en-US" sz="900" b="1" dirty="0">
                 <a:solidFill>
                   <a:srgbClr val="5A6275"/>
                 </a:solidFill>
               </a:rPr>
-              <a:t>SHARE OF VOICE GEO</a:t>
-            </a:r>
-            <a:endParaRPr lang="en-US" sz="1100" dirty="0"/>
-          </a:p>
-        </p:txBody>
-      </p:sp>
-      <p:sp>
-        <p:nvSpPr>
-          <p:cNvPr id="21" name="Text 19"/>
+              <a:t>MENTIONS CONVERSATIONNELLES</a:t>
+            </a:r>
+            <a:endParaRPr lang="en-US" sz="900" dirty="0"/>
+          </a:p>
+        </p:txBody>
+      </p:sp>
+      <p:sp>
+        <p:nvSpPr>
+          <p:cNvPr id="8" name="Text 6"/>
           <p:cNvSpPr txBox="1"/>
           <p:nvPr/>
         </p:nvSpPr>
         <p:spPr>
           <a:xfrm>
-            <a:off x="731520" y="4251960"/>
-            <a:ext cx="2286000" cy="548640"/>
+            <a:off x="658368" y="2468880"/>
+            <a:ext cx="1536192" cy="411480"/>
           </a:xfrm>
           <a:prstGeom prst="rect">
             <a:avLst/>
@@ -6965,27 +6485,27 @@
               <a:buNone/>
             </a:pPr>
             <a:r>
-              <a:rPr lang="en-US" sz="3000" b="1" dirty="0">
+              <a:rPr lang="en-US" sz="2000" b="1" dirty="0">
                 <a:solidFill>
                   <a:srgbClr val="1B2238"/>
                 </a:solidFill>
               </a:rPr>
-              <a:t>7,8 %</a:t>
-            </a:r>
-            <a:endParaRPr lang="en-US" sz="3000" dirty="0"/>
-          </a:p>
-        </p:txBody>
-      </p:sp>
-      <p:sp>
-        <p:nvSpPr>
-          <p:cNvPr id="22" name="Text 20"/>
+              <a:t>1 311 465</a:t>
+            </a:r>
+            <a:endParaRPr lang="en-US" sz="2000" dirty="0"/>
+          </a:p>
+        </p:txBody>
+      </p:sp>
+      <p:sp>
+        <p:nvSpPr>
+          <p:cNvPr id="9" name="Text 7"/>
           <p:cNvSpPr txBox="1"/>
           <p:nvPr/>
         </p:nvSpPr>
         <p:spPr>
           <a:xfrm>
-            <a:off x="731520" y="4846320"/>
-            <a:ext cx="2286000" cy="320040"/>
+            <a:off x="658368" y="2880360"/>
+            <a:ext cx="1536192" cy="502920"/>
           </a:xfrm>
           <a:prstGeom prst="rect">
             <a:avLst/>
@@ -6994,38 +6514,52 @@
           <a:ln/>
         </p:spPr>
         <p:txBody>
-          <a:bodyPr wrap="square" lIns="0" tIns="0" rIns="0" bIns="0" rtlCol="0" anchor="ctr"/>
+          <a:bodyPr wrap="square" lIns="0" tIns="0" rIns="0" bIns="0" rtlCol="0" anchor="t"/>
           <a:lstStyle/>
           <a:p>
             <a:pPr indent="0" marL="0">
               <a:buNone/>
             </a:pPr>
             <a:r>
-              <a:rPr lang="en-US" sz="1200" b="1" dirty="0">
+              <a:rPr lang="en-US" sz="1000" b="1" dirty="0">
                 <a:solidFill>
                   <a:srgbClr val="2E9E6B"/>
                 </a:solidFill>
               </a:rPr>
-              <a:t>▲ +2,5 pts  vs 23/09 → 30/09</a:t>
-            </a:r>
-            <a:endParaRPr lang="en-US" sz="1200" dirty="0"/>
-          </a:p>
-        </p:txBody>
-      </p:sp>
-      <p:sp>
-        <p:nvSpPr>
-          <p:cNvPr id="23" name="Shape 21"/>
+              <a:t>▲ +16,7 %</a:t>
+            </a:r>
+            <a:endParaRPr lang="en-US" sz="1000" dirty="0"/>
+          </a:p>
+          <a:p>
+            <a:pPr indent="0" marL="0">
+              <a:buNone/>
+            </a:pPr>
+            <a:r>
+              <a:rPr lang="en-US" sz="1000" dirty="0">
+                <a:solidFill>
+                  <a:srgbClr val="5A6275"/>
+                </a:solidFill>
+              </a:rPr>
+              <a:t>YTD 4 475 698</a:t>
+            </a:r>
+            <a:endParaRPr lang="en-US" sz="1000" dirty="0"/>
+          </a:p>
+        </p:txBody>
+      </p:sp>
+      <p:sp>
+        <p:nvSpPr>
+          <p:cNvPr id="10" name="Shape 8"/>
           <p:cNvSpPr/>
           <p:nvPr/>
         </p:nvSpPr>
         <p:spPr>
           <a:xfrm>
-            <a:off x="3353105" y="3886200"/>
-            <a:ext cx="2651760" cy="1417320"/>
+            <a:off x="2410358" y="2057400"/>
+            <a:ext cx="1755648" cy="1371600"/>
           </a:xfrm>
           <a:prstGeom prst="roundRect">
             <a:avLst>
-              <a:gd name="adj" fmla="val 6452"/>
+              <a:gd name="adj" fmla="val 5333"/>
             </a:avLst>
           </a:prstGeom>
           <a:solidFill>
@@ -7041,14 +6575,14 @@
       </p:sp>
       <p:sp>
         <p:nvSpPr>
-          <p:cNvPr id="24" name="Text 22"/>
+          <p:cNvPr id="11" name="Text 9"/>
           <p:cNvSpPr txBox="1"/>
           <p:nvPr/>
         </p:nvSpPr>
         <p:spPr>
           <a:xfrm>
-            <a:off x="3535985" y="3977640"/>
-            <a:ext cx="2286000" cy="274320"/>
+            <a:off x="2520086" y="2130552"/>
+            <a:ext cx="1536192" cy="329184"/>
           </a:xfrm>
           <a:prstGeom prst="rect">
             <a:avLst/>
@@ -7057,34 +6591,34 @@
           <a:ln/>
         </p:spPr>
         <p:txBody>
-          <a:bodyPr wrap="square" lIns="0" tIns="0" rIns="0" bIns="0" rtlCol="0" anchor="ctr"/>
+          <a:bodyPr wrap="square" lIns="0" tIns="0" rIns="0" bIns="0" rtlCol="0" anchor="t"/>
           <a:lstStyle/>
           <a:p>
             <a:pPr indent="0" marL="0">
               <a:buNone/>
             </a:pPr>
             <a:r>
-              <a:rPr lang="en-US" sz="1100" b="1" dirty="0">
+              <a:rPr lang="en-US" sz="900" b="1" dirty="0">
                 <a:solidFill>
                   <a:srgbClr val="5A6275"/>
                 </a:solidFill>
               </a:rPr>
-              <a:t>SHARE OF VOICE GEA (ADS)</a:t>
-            </a:r>
-            <a:endParaRPr lang="en-US" sz="1100" dirty="0"/>
-          </a:p>
-        </p:txBody>
-      </p:sp>
-      <p:sp>
-        <p:nvSpPr>
-          <p:cNvPr id="25" name="Text 23"/>
+              <a:t>TRAFIC LLM QUALIFIÉ</a:t>
+            </a:r>
+            <a:endParaRPr lang="en-US" sz="900" dirty="0"/>
+          </a:p>
+        </p:txBody>
+      </p:sp>
+      <p:sp>
+        <p:nvSpPr>
+          <p:cNvPr id="12" name="Text 10"/>
           <p:cNvSpPr txBox="1"/>
           <p:nvPr/>
         </p:nvSpPr>
         <p:spPr>
           <a:xfrm>
-            <a:off x="3535985" y="4251960"/>
-            <a:ext cx="2286000" cy="548640"/>
+            <a:off x="2520086" y="2468880"/>
+            <a:ext cx="1536192" cy="411480"/>
           </a:xfrm>
           <a:prstGeom prst="rect">
             <a:avLst/>
@@ -7100,27 +6634,27 @@
               <a:buNone/>
             </a:pPr>
             <a:r>
-              <a:rPr lang="en-US" sz="3000" b="1" dirty="0">
+              <a:rPr lang="en-US" sz="2000" b="1" dirty="0">
                 <a:solidFill>
                   <a:srgbClr val="1B2238"/>
                 </a:solidFill>
               </a:rPr>
-              <a:t>20,2 %</a:t>
-            </a:r>
-            <a:endParaRPr lang="en-US" sz="3000" dirty="0"/>
-          </a:p>
-        </p:txBody>
-      </p:sp>
-      <p:sp>
-        <p:nvSpPr>
-          <p:cNvPr id="26" name="Text 24"/>
+              <a:t>6 468</a:t>
+            </a:r>
+            <a:endParaRPr lang="en-US" sz="2000" dirty="0"/>
+          </a:p>
+        </p:txBody>
+      </p:sp>
+      <p:sp>
+        <p:nvSpPr>
+          <p:cNvPr id="13" name="Text 11"/>
           <p:cNvSpPr txBox="1"/>
           <p:nvPr/>
         </p:nvSpPr>
         <p:spPr>
           <a:xfrm>
-            <a:off x="3535985" y="4846320"/>
-            <a:ext cx="2286000" cy="320040"/>
+            <a:off x="2520086" y="2880360"/>
+            <a:ext cx="1536192" cy="502920"/>
           </a:xfrm>
           <a:prstGeom prst="rect">
             <a:avLst/>
@@ -7129,38 +6663,52 @@
           <a:ln/>
         </p:spPr>
         <p:txBody>
-          <a:bodyPr wrap="square" lIns="0" tIns="0" rIns="0" bIns="0" rtlCol="0" anchor="ctr"/>
+          <a:bodyPr wrap="square" lIns="0" tIns="0" rIns="0" bIns="0" rtlCol="0" anchor="t"/>
           <a:lstStyle/>
           <a:p>
             <a:pPr indent="0" marL="0">
               <a:buNone/>
             </a:pPr>
             <a:r>
-              <a:rPr lang="en-US" sz="1200" b="1" dirty="0">
+              <a:rPr lang="en-US" sz="1000" b="1" dirty="0">
                 <a:solidFill>
                   <a:srgbClr val="C8372D"/>
                 </a:solidFill>
               </a:rPr>
-              <a:t>▼ -2,8 pts  vs 23/09 → 30/09</a:t>
-            </a:r>
-            <a:endParaRPr lang="en-US" sz="1200" dirty="0"/>
-          </a:p>
-        </p:txBody>
-      </p:sp>
-      <p:sp>
-        <p:nvSpPr>
-          <p:cNvPr id="27" name="Shape 25"/>
+              <a:t>▼ -11,3 %</a:t>
+            </a:r>
+            <a:endParaRPr lang="en-US" sz="1000" dirty="0"/>
+          </a:p>
+          <a:p>
+            <a:pPr indent="0" marL="0">
+              <a:buNone/>
+            </a:pPr>
+            <a:r>
+              <a:rPr lang="en-US" sz="1000" dirty="0">
+                <a:solidFill>
+                  <a:srgbClr val="5A6275"/>
+                </a:solidFill>
+              </a:rPr>
+              <a:t>YTD 26 646</a:t>
+            </a:r>
+            <a:endParaRPr lang="en-US" sz="1000" dirty="0"/>
+          </a:p>
+        </p:txBody>
+      </p:sp>
+      <p:sp>
+        <p:nvSpPr>
+          <p:cNvPr id="14" name="Shape 12"/>
           <p:cNvSpPr/>
           <p:nvPr/>
         </p:nvSpPr>
         <p:spPr>
           <a:xfrm>
-            <a:off x="6157570" y="3886200"/>
-            <a:ext cx="2651760" cy="1417320"/>
+            <a:off x="4272077" y="2057400"/>
+            <a:ext cx="1755648" cy="1371600"/>
           </a:xfrm>
           <a:prstGeom prst="roundRect">
             <a:avLst>
-              <a:gd name="adj" fmla="val 6452"/>
+              <a:gd name="adj" fmla="val 5333"/>
             </a:avLst>
           </a:prstGeom>
           <a:solidFill>
@@ -7176,14 +6724,14 @@
       </p:sp>
       <p:sp>
         <p:nvSpPr>
-          <p:cNvPr id="28" name="Text 26"/>
+          <p:cNvPr id="15" name="Text 13"/>
           <p:cNvSpPr txBox="1"/>
           <p:nvPr/>
         </p:nvSpPr>
         <p:spPr>
           <a:xfrm>
-            <a:off x="6340450" y="3977640"/>
-            <a:ext cx="2286000" cy="274320"/>
+            <a:off x="4381805" y="2130552"/>
+            <a:ext cx="1536192" cy="329184"/>
           </a:xfrm>
           <a:prstGeom prst="rect">
             <a:avLst/>
@@ -7192,34 +6740,34 @@
           <a:ln/>
         </p:spPr>
         <p:txBody>
-          <a:bodyPr wrap="square" lIns="0" tIns="0" rIns="0" bIns="0" rtlCol="0" anchor="ctr"/>
+          <a:bodyPr wrap="square" lIns="0" tIns="0" rIns="0" bIns="0" rtlCol="0" anchor="t"/>
           <a:lstStyle/>
           <a:p>
             <a:pPr indent="0" marL="0">
               <a:buNone/>
             </a:pPr>
             <a:r>
-              <a:rPr lang="en-US" sz="1100" b="1" dirty="0">
+              <a:rPr lang="en-US" sz="900" b="1" dirty="0">
                 <a:solidFill>
                   <a:srgbClr val="5A6275"/>
                 </a:solidFill>
               </a:rPr>
-              <a:t>SHARE OF VOICE</a:t>
-            </a:r>
-            <a:endParaRPr lang="en-US" sz="1100" dirty="0"/>
-          </a:p>
-        </p:txBody>
-      </p:sp>
-      <p:sp>
-        <p:nvSpPr>
-          <p:cNvPr id="29" name="Text 27"/>
+              <a:t>CTR</a:t>
+            </a:r>
+            <a:endParaRPr lang="en-US" sz="900" dirty="0"/>
+          </a:p>
+        </p:txBody>
+      </p:sp>
+      <p:sp>
+        <p:nvSpPr>
+          <p:cNvPr id="16" name="Text 14"/>
           <p:cNvSpPr txBox="1"/>
           <p:nvPr/>
         </p:nvSpPr>
         <p:spPr>
           <a:xfrm>
-            <a:off x="6340450" y="4251960"/>
-            <a:ext cx="2286000" cy="548640"/>
+            <a:off x="4381805" y="2468880"/>
+            <a:ext cx="1536192" cy="411480"/>
           </a:xfrm>
           <a:prstGeom prst="rect">
             <a:avLst/>
@@ -7235,27 +6783,27 @@
               <a:buNone/>
             </a:pPr>
             <a:r>
-              <a:rPr lang="en-US" sz="3000" b="1" dirty="0">
+              <a:rPr lang="en-US" sz="2000" b="1" dirty="0">
                 <a:solidFill>
                   <a:srgbClr val="1B2238"/>
                 </a:solidFill>
               </a:rPr>
-              <a:t>4,3 %</a:t>
-            </a:r>
-            <a:endParaRPr lang="en-US" sz="3000" dirty="0"/>
-          </a:p>
-        </p:txBody>
-      </p:sp>
-      <p:sp>
-        <p:nvSpPr>
-          <p:cNvPr id="30" name="Text 28"/>
+              <a:t>0,49 %</a:t>
+            </a:r>
+            <a:endParaRPr lang="en-US" sz="2000" dirty="0"/>
+          </a:p>
+        </p:txBody>
+      </p:sp>
+      <p:sp>
+        <p:nvSpPr>
+          <p:cNvPr id="17" name="Text 15"/>
           <p:cNvSpPr txBox="1"/>
           <p:nvPr/>
         </p:nvSpPr>
         <p:spPr>
           <a:xfrm>
-            <a:off x="6340450" y="4846320"/>
-            <a:ext cx="2286000" cy="320040"/>
+            <a:off x="4381805" y="2880360"/>
+            <a:ext cx="1536192" cy="502920"/>
           </a:xfrm>
           <a:prstGeom prst="rect">
             <a:avLst/>
@@ -7264,38 +6812,52 @@
           <a:ln/>
         </p:spPr>
         <p:txBody>
-          <a:bodyPr wrap="square" lIns="0" tIns="0" rIns="0" bIns="0" rtlCol="0" anchor="ctr"/>
+          <a:bodyPr wrap="square" lIns="0" tIns="0" rIns="0" bIns="0" rtlCol="0" anchor="t"/>
           <a:lstStyle/>
           <a:p>
             <a:pPr indent="0" marL="0">
               <a:buNone/>
             </a:pPr>
             <a:r>
-              <a:rPr lang="en-US" sz="1200" b="1" dirty="0">
-                <a:solidFill>
-                  <a:srgbClr val="2E9E6B"/>
-                </a:solidFill>
-              </a:rPr>
-              <a:t>▲ +0,3 pt  vs 23/09 → 30/09</a:t>
-            </a:r>
-            <a:endParaRPr lang="en-US" sz="1200" dirty="0"/>
-          </a:p>
-        </p:txBody>
-      </p:sp>
-      <p:sp>
-        <p:nvSpPr>
-          <p:cNvPr id="31" name="Shape 29"/>
+              <a:rPr lang="en-US" sz="1000" b="1" dirty="0">
+                <a:solidFill>
+                  <a:srgbClr val="C8372D"/>
+                </a:solidFill>
+              </a:rPr>
+              <a:t>▼ -0,16 pt</a:t>
+            </a:r>
+            <a:endParaRPr lang="en-US" sz="1000" dirty="0"/>
+          </a:p>
+          <a:p>
+            <a:pPr indent="0" marL="0">
+              <a:buNone/>
+            </a:pPr>
+            <a:r>
+              <a:rPr lang="en-US" sz="1000" dirty="0">
+                <a:solidFill>
+                  <a:srgbClr val="5A6275"/>
+                </a:solidFill>
+              </a:rPr>
+              <a:t>YTD 0,60 %</a:t>
+            </a:r>
+            <a:endParaRPr lang="en-US" sz="1000" dirty="0"/>
+          </a:p>
+        </p:txBody>
+      </p:sp>
+      <p:sp>
+        <p:nvSpPr>
+          <p:cNvPr id="18" name="Shape 16"/>
           <p:cNvSpPr/>
           <p:nvPr/>
         </p:nvSpPr>
         <p:spPr>
           <a:xfrm>
-            <a:off x="8962034" y="3886200"/>
-            <a:ext cx="2651760" cy="1417320"/>
+            <a:off x="6133795" y="2057400"/>
+            <a:ext cx="1755648" cy="1371600"/>
           </a:xfrm>
           <a:prstGeom prst="roundRect">
             <a:avLst>
-              <a:gd name="adj" fmla="val 6452"/>
+              <a:gd name="adj" fmla="val 5333"/>
             </a:avLst>
           </a:prstGeom>
           <a:solidFill>
@@ -7311,14 +6873,14 @@
       </p:sp>
       <p:sp>
         <p:nvSpPr>
-          <p:cNvPr id="32" name="Text 30"/>
+          <p:cNvPr id="19" name="Text 17"/>
           <p:cNvSpPr txBox="1"/>
           <p:nvPr/>
         </p:nvSpPr>
         <p:spPr>
           <a:xfrm>
-            <a:off x="9144914" y="3977640"/>
-            <a:ext cx="2286000" cy="274320"/>
+            <a:off x="6243523" y="2130552"/>
+            <a:ext cx="1536192" cy="329184"/>
           </a:xfrm>
           <a:prstGeom prst="rect">
             <a:avLst/>
@@ -7327,34 +6889,34 @@
           <a:ln/>
         </p:spPr>
         <p:txBody>
-          <a:bodyPr wrap="square" lIns="0" tIns="0" rIns="0" bIns="0" rtlCol="0" anchor="ctr"/>
+          <a:bodyPr wrap="square" lIns="0" tIns="0" rIns="0" bIns="0" rtlCol="0" anchor="t"/>
           <a:lstStyle/>
           <a:p>
             <a:pPr indent="0" marL="0">
               <a:buNone/>
             </a:pPr>
             <a:r>
-              <a:rPr lang="en-US" sz="1100" b="1" dirty="0">
+              <a:rPr lang="en-US" sz="900" b="1" dirty="0">
                 <a:solidFill>
                   <a:srgbClr val="5A6275"/>
                 </a:solidFill>
               </a:rPr>
-              <a:t>LONGUEUR DES REQUÊTES</a:t>
-            </a:r>
-            <a:endParaRPr lang="en-US" sz="1100" dirty="0"/>
-          </a:p>
-        </p:txBody>
-      </p:sp>
-      <p:sp>
-        <p:nvSpPr>
-          <p:cNvPr id="33" name="Text 31"/>
+              <a:t>CPC MOYEN</a:t>
+            </a:r>
+            <a:endParaRPr lang="en-US" sz="900" dirty="0"/>
+          </a:p>
+        </p:txBody>
+      </p:sp>
+      <p:sp>
+        <p:nvSpPr>
+          <p:cNvPr id="20" name="Text 18"/>
           <p:cNvSpPr txBox="1"/>
           <p:nvPr/>
         </p:nvSpPr>
         <p:spPr>
           <a:xfrm>
-            <a:off x="9144914" y="4251960"/>
-            <a:ext cx="2286000" cy="548640"/>
+            <a:off x="6243523" y="2468880"/>
+            <a:ext cx="1536192" cy="411480"/>
           </a:xfrm>
           <a:prstGeom prst="rect">
             <a:avLst/>
@@ -7370,27 +6932,27 @@
               <a:buNone/>
             </a:pPr>
             <a:r>
-              <a:rPr lang="en-US" sz="3000" b="1" dirty="0">
+              <a:rPr lang="en-US" sz="2000" b="1" dirty="0">
                 <a:solidFill>
                   <a:srgbClr val="1B2238"/>
                 </a:solidFill>
               </a:rPr>
-              <a:t>8,2 mots</a:t>
-            </a:r>
-            <a:endParaRPr lang="en-US" sz="3000" dirty="0"/>
-          </a:p>
-        </p:txBody>
-      </p:sp>
-      <p:sp>
-        <p:nvSpPr>
-          <p:cNvPr id="34" name="Text 32"/>
+              <a:t>0,37 €</a:t>
+            </a:r>
+            <a:endParaRPr lang="en-US" sz="2000" dirty="0"/>
+          </a:p>
+        </p:txBody>
+      </p:sp>
+      <p:sp>
+        <p:nvSpPr>
+          <p:cNvPr id="21" name="Text 19"/>
           <p:cNvSpPr txBox="1"/>
           <p:nvPr/>
         </p:nvSpPr>
         <p:spPr>
           <a:xfrm>
-            <a:off x="9144914" y="4846320"/>
-            <a:ext cx="2286000" cy="320040"/>
+            <a:off x="6243523" y="2880360"/>
+            <a:ext cx="1536192" cy="502920"/>
           </a:xfrm>
           <a:prstGeom prst="rect">
             <a:avLst/>
@@ -7399,38 +6961,52 @@
           <a:ln/>
         </p:spPr>
         <p:txBody>
-          <a:bodyPr wrap="square" lIns="0" tIns="0" rIns="0" bIns="0" rtlCol="0" anchor="ctr"/>
+          <a:bodyPr wrap="square" lIns="0" tIns="0" rIns="0" bIns="0" rtlCol="0" anchor="t"/>
           <a:lstStyle/>
           <a:p>
             <a:pPr indent="0" marL="0">
               <a:buNone/>
             </a:pPr>
             <a:r>
-              <a:rPr lang="en-US" sz="1200" b="1" dirty="0">
-                <a:solidFill>
-                  <a:srgbClr val="2E9E6B"/>
-                </a:solidFill>
-              </a:rPr>
-              <a:t>▲ +10,6 %  vs 23/09 → 30/09</a:t>
-            </a:r>
-            <a:endParaRPr lang="en-US" sz="1200" dirty="0"/>
-          </a:p>
-        </p:txBody>
-      </p:sp>
-      <p:sp>
-        <p:nvSpPr>
-          <p:cNvPr id="35" name="Shape 33"/>
+              <a:rPr lang="en-US" sz="1000" b="1" dirty="0">
+                <a:solidFill>
+                  <a:srgbClr val="C8372D"/>
+                </a:solidFill>
+              </a:rPr>
+              <a:t>▲ +26,6 %</a:t>
+            </a:r>
+            <a:endParaRPr lang="en-US" sz="1000" dirty="0"/>
+          </a:p>
+          <a:p>
+            <a:pPr indent="0" marL="0">
+              <a:buNone/>
+            </a:pPr>
+            <a:r>
+              <a:rPr lang="en-US" sz="1000" dirty="0">
+                <a:solidFill>
+                  <a:srgbClr val="5A6275"/>
+                </a:solidFill>
+              </a:rPr>
+              <a:t>YTD 0,27 €</a:t>
+            </a:r>
+            <a:endParaRPr lang="en-US" sz="1000" dirty="0"/>
+          </a:p>
+        </p:txBody>
+      </p:sp>
+      <p:sp>
+        <p:nvSpPr>
+          <p:cNvPr id="22" name="Shape 20"/>
           <p:cNvSpPr/>
           <p:nvPr/>
         </p:nvSpPr>
         <p:spPr>
           <a:xfrm>
-            <a:off x="548640" y="5486400"/>
-            <a:ext cx="11064240" cy="566928"/>
+            <a:off x="7995514" y="2057400"/>
+            <a:ext cx="1755648" cy="1371600"/>
           </a:xfrm>
           <a:prstGeom prst="roundRect">
             <a:avLst>
-              <a:gd name="adj" fmla="val 12903"/>
+              <a:gd name="adj" fmla="val 5333"/>
             </a:avLst>
           </a:prstGeom>
           <a:solidFill>
@@ -7446,12 +7022,886 @@
       </p:sp>
       <p:sp>
         <p:nvSpPr>
+          <p:cNvPr id="23" name="Text 21"/>
+          <p:cNvSpPr txBox="1"/>
+          <p:nvPr/>
+        </p:nvSpPr>
+        <p:spPr>
+          <a:xfrm>
+            <a:off x="8105242" y="2130552"/>
+            <a:ext cx="1536192" cy="329184"/>
+          </a:xfrm>
+          <a:prstGeom prst="rect">
+            <a:avLst/>
+          </a:prstGeom>
+          <a:noFill/>
+          <a:ln/>
+        </p:spPr>
+        <p:txBody>
+          <a:bodyPr wrap="square" lIns="0" tIns="0" rIns="0" bIns="0" rtlCol="0" anchor="t"/>
+          <a:lstStyle/>
+          <a:p>
+            <a:pPr indent="0" marL="0">
+              <a:buNone/>
+            </a:pPr>
+            <a:r>
+              <a:rPr lang="en-US" sz="900" b="1" dirty="0">
+                <a:solidFill>
+                  <a:srgbClr val="5A6275"/>
+                </a:solidFill>
+              </a:rPr>
+              <a:t>CONVERSIONS LAST CLICK</a:t>
+            </a:r>
+            <a:endParaRPr lang="en-US" sz="900" dirty="0"/>
+          </a:p>
+        </p:txBody>
+      </p:sp>
+      <p:sp>
+        <p:nvSpPr>
+          <p:cNvPr id="24" name="Text 22"/>
+          <p:cNvSpPr txBox="1"/>
+          <p:nvPr/>
+        </p:nvSpPr>
+        <p:spPr>
+          <a:xfrm>
+            <a:off x="8105242" y="2468880"/>
+            <a:ext cx="1536192" cy="411480"/>
+          </a:xfrm>
+          <a:prstGeom prst="rect">
+            <a:avLst/>
+          </a:prstGeom>
+          <a:noFill/>
+          <a:ln/>
+        </p:spPr>
+        <p:txBody>
+          <a:bodyPr wrap="square" lIns="0" tIns="0" rIns="0" bIns="0" rtlCol="0" anchor="ctr"/>
+          <a:lstStyle/>
+          <a:p>
+            <a:pPr indent="0" marL="0">
+              <a:buNone/>
+            </a:pPr>
+            <a:r>
+              <a:rPr lang="en-US" sz="2000" b="1" dirty="0">
+                <a:solidFill>
+                  <a:srgbClr val="1B2238"/>
+                </a:solidFill>
+              </a:rPr>
+              <a:t>n. d.</a:t>
+            </a:r>
+            <a:endParaRPr lang="en-US" sz="2000" dirty="0"/>
+          </a:p>
+        </p:txBody>
+      </p:sp>
+      <p:sp>
+        <p:nvSpPr>
+          <p:cNvPr id="25" name="Text 23"/>
+          <p:cNvSpPr txBox="1"/>
+          <p:nvPr/>
+        </p:nvSpPr>
+        <p:spPr>
+          <a:xfrm>
+            <a:off x="8105242" y="2880360"/>
+            <a:ext cx="1536192" cy="502920"/>
+          </a:xfrm>
+          <a:prstGeom prst="rect">
+            <a:avLst/>
+          </a:prstGeom>
+          <a:noFill/>
+          <a:ln/>
+        </p:spPr>
+        <p:txBody>
+          <a:bodyPr wrap="square" lIns="0" tIns="0" rIns="0" bIns="0" rtlCol="0" anchor="t"/>
+          <a:lstStyle/>
+          <a:p>
+            <a:pPr indent="0" marL="0">
+              <a:buNone/>
+            </a:pPr>
+            <a:r>
+              <a:rPr lang="en-US" sz="1000" b="1" dirty="0">
+                <a:solidFill>
+                  <a:srgbClr val="5A6275"/>
+                </a:solidFill>
+              </a:rPr>
+              <a:t>—</a:t>
+            </a:r>
+            <a:endParaRPr lang="en-US" sz="1000" dirty="0"/>
+          </a:p>
+          <a:p>
+            <a:pPr indent="0" marL="0">
+              <a:buNone/>
+            </a:pPr>
+            <a:r>
+              <a:rPr lang="en-US" sz="1000" dirty="0">
+                <a:solidFill>
+                  <a:srgbClr val="5A6275"/>
+                </a:solidFill>
+              </a:rPr>
+              <a:t>Tracker en cours</a:t>
+            </a:r>
+            <a:endParaRPr lang="en-US" sz="1000" dirty="0"/>
+          </a:p>
+        </p:txBody>
+      </p:sp>
+      <p:sp>
+        <p:nvSpPr>
+          <p:cNvPr id="26" name="Shape 24"/>
+          <p:cNvSpPr/>
+          <p:nvPr/>
+        </p:nvSpPr>
+        <p:spPr>
+          <a:xfrm>
+            <a:off x="9857232" y="2057400"/>
+            <a:ext cx="1755648" cy="1371600"/>
+          </a:xfrm>
+          <a:prstGeom prst="roundRect">
+            <a:avLst>
+              <a:gd name="adj" fmla="val 5333"/>
+            </a:avLst>
+          </a:prstGeom>
+          <a:solidFill>
+            <a:srgbClr val="F2F4F8"/>
+          </a:solidFill>
+          <a:ln w="12700">
+            <a:solidFill>
+              <a:srgbClr val="F2F4F8"/>
+            </a:solidFill>
+            <a:prstDash val="solid"/>
+          </a:ln>
+        </p:spPr>
+      </p:sp>
+      <p:sp>
+        <p:nvSpPr>
+          <p:cNvPr id="27" name="Text 25"/>
+          <p:cNvSpPr txBox="1"/>
+          <p:nvPr/>
+        </p:nvSpPr>
+        <p:spPr>
+          <a:xfrm>
+            <a:off x="9966960" y="2130552"/>
+            <a:ext cx="1536192" cy="329184"/>
+          </a:xfrm>
+          <a:prstGeom prst="rect">
+            <a:avLst/>
+          </a:prstGeom>
+          <a:noFill/>
+          <a:ln/>
+        </p:spPr>
+        <p:txBody>
+          <a:bodyPr wrap="square" lIns="0" tIns="0" rIns="0" bIns="0" rtlCol="0" anchor="t"/>
+          <a:lstStyle/>
+          <a:p>
+            <a:pPr indent="0" marL="0">
+              <a:buNone/>
+            </a:pPr>
+            <a:r>
+              <a:rPr lang="en-US" sz="900" b="1" dirty="0">
+                <a:solidFill>
+                  <a:srgbClr val="5A6275"/>
+                </a:solidFill>
+              </a:rPr>
+              <a:t>CVR LAST CLICK</a:t>
+            </a:r>
+            <a:endParaRPr lang="en-US" sz="900" dirty="0"/>
+          </a:p>
+        </p:txBody>
+      </p:sp>
+      <p:sp>
+        <p:nvSpPr>
+          <p:cNvPr id="28" name="Text 26"/>
+          <p:cNvSpPr txBox="1"/>
+          <p:nvPr/>
+        </p:nvSpPr>
+        <p:spPr>
+          <a:xfrm>
+            <a:off x="9966960" y="2468880"/>
+            <a:ext cx="1536192" cy="411480"/>
+          </a:xfrm>
+          <a:prstGeom prst="rect">
+            <a:avLst/>
+          </a:prstGeom>
+          <a:noFill/>
+          <a:ln/>
+        </p:spPr>
+        <p:txBody>
+          <a:bodyPr wrap="square" lIns="0" tIns="0" rIns="0" bIns="0" rtlCol="0" anchor="ctr"/>
+          <a:lstStyle/>
+          <a:p>
+            <a:pPr indent="0" marL="0">
+              <a:buNone/>
+            </a:pPr>
+            <a:r>
+              <a:rPr lang="en-US" sz="2000" b="1" dirty="0">
+                <a:solidFill>
+                  <a:srgbClr val="1B2238"/>
+                </a:solidFill>
+              </a:rPr>
+              <a:t>n. d.</a:t>
+            </a:r>
+            <a:endParaRPr lang="en-US" sz="2000" dirty="0"/>
+          </a:p>
+        </p:txBody>
+      </p:sp>
+      <p:sp>
+        <p:nvSpPr>
+          <p:cNvPr id="29" name="Text 27"/>
+          <p:cNvSpPr txBox="1"/>
+          <p:nvPr/>
+        </p:nvSpPr>
+        <p:spPr>
+          <a:xfrm>
+            <a:off x="9966960" y="2880360"/>
+            <a:ext cx="1536192" cy="502920"/>
+          </a:xfrm>
+          <a:prstGeom prst="rect">
+            <a:avLst/>
+          </a:prstGeom>
+          <a:noFill/>
+          <a:ln/>
+        </p:spPr>
+        <p:txBody>
+          <a:bodyPr wrap="square" lIns="0" tIns="0" rIns="0" bIns="0" rtlCol="0" anchor="t"/>
+          <a:lstStyle/>
+          <a:p>
+            <a:pPr indent="0" marL="0">
+              <a:buNone/>
+            </a:pPr>
+            <a:r>
+              <a:rPr lang="en-US" sz="1000" b="1" dirty="0">
+                <a:solidFill>
+                  <a:srgbClr val="5A6275"/>
+                </a:solidFill>
+              </a:rPr>
+              <a:t>—</a:t>
+            </a:r>
+            <a:endParaRPr lang="en-US" sz="1000" dirty="0"/>
+          </a:p>
+          <a:p>
+            <a:pPr indent="0" marL="0">
+              <a:buNone/>
+            </a:pPr>
+            <a:r>
+              <a:rPr lang="en-US" sz="1000" dirty="0">
+                <a:solidFill>
+                  <a:srgbClr val="5A6275"/>
+                </a:solidFill>
+              </a:rPr>
+              <a:t>Tracker en cours</a:t>
+            </a:r>
+            <a:endParaRPr lang="en-US" sz="1000" dirty="0"/>
+          </a:p>
+        </p:txBody>
+      </p:sp>
+      <p:sp>
+        <p:nvSpPr>
+          <p:cNvPr id="30" name="Text 28"/>
+          <p:cNvSpPr txBox="1"/>
+          <p:nvPr/>
+        </p:nvSpPr>
+        <p:spPr>
+          <a:xfrm>
+            <a:off x="548640" y="3566160"/>
+            <a:ext cx="5486400" cy="274320"/>
+          </a:xfrm>
+          <a:prstGeom prst="rect">
+            <a:avLst/>
+          </a:prstGeom>
+          <a:noFill/>
+          <a:ln/>
+        </p:spPr>
+        <p:txBody>
+          <a:bodyPr wrap="square" lIns="0" tIns="0" rIns="0" bIns="0" rtlCol="0" anchor="ctr"/>
+          <a:lstStyle/>
+          <a:p>
+            <a:pPr indent="0" marL="0">
+              <a:buNone/>
+            </a:pPr>
+            <a:r>
+              <a:rPr lang="en-US" sz="1200" b="1" dirty="0">
+                <a:solidFill>
+                  <a:srgbClr val="E8601C"/>
+                </a:solidFill>
+              </a:rPr>
+              <a:t>VISIBILITÉ DANS LES RÉPONSES DE L'IA</a:t>
+            </a:r>
+            <a:endParaRPr lang="en-US" sz="1200" dirty="0"/>
+          </a:p>
+        </p:txBody>
+      </p:sp>
+      <p:sp>
+        <p:nvSpPr>
+          <p:cNvPr id="31" name="Shape 29"/>
+          <p:cNvSpPr/>
+          <p:nvPr/>
+        </p:nvSpPr>
+        <p:spPr>
+          <a:xfrm>
+            <a:off x="548640" y="3886200"/>
+            <a:ext cx="2651760" cy="1417320"/>
+          </a:xfrm>
+          <a:prstGeom prst="roundRect">
+            <a:avLst>
+              <a:gd name="adj" fmla="val 6452"/>
+            </a:avLst>
+          </a:prstGeom>
+          <a:solidFill>
+            <a:srgbClr val="F2F4F8"/>
+          </a:solidFill>
+          <a:ln w="12700">
+            <a:solidFill>
+              <a:srgbClr val="F2F4F8"/>
+            </a:solidFill>
+            <a:prstDash val="solid"/>
+          </a:ln>
+        </p:spPr>
+      </p:sp>
+      <p:sp>
+        <p:nvSpPr>
+          <p:cNvPr id="32" name="Text 30"/>
+          <p:cNvSpPr txBox="1"/>
+          <p:nvPr/>
+        </p:nvSpPr>
+        <p:spPr>
+          <a:xfrm>
+            <a:off x="731520" y="3977640"/>
+            <a:ext cx="2286000" cy="274320"/>
+          </a:xfrm>
+          <a:prstGeom prst="rect">
+            <a:avLst/>
+          </a:prstGeom>
+          <a:noFill/>
+          <a:ln/>
+        </p:spPr>
+        <p:txBody>
+          <a:bodyPr wrap="square" lIns="0" tIns="0" rIns="0" bIns="0" rtlCol="0" anchor="ctr"/>
+          <a:lstStyle/>
+          <a:p>
+            <a:pPr indent="0" marL="0">
+              <a:buNone/>
+            </a:pPr>
+            <a:r>
+              <a:rPr lang="en-US" sz="1100" b="1" dirty="0">
+                <a:solidFill>
+                  <a:srgbClr val="5A6275"/>
+                </a:solidFill>
+              </a:rPr>
+              <a:t>SHARE OF VOICE GEO</a:t>
+            </a:r>
+            <a:endParaRPr lang="en-US" sz="1100" dirty="0"/>
+          </a:p>
+        </p:txBody>
+      </p:sp>
+      <p:sp>
+        <p:nvSpPr>
+          <p:cNvPr id="33" name="Text 31"/>
+          <p:cNvSpPr txBox="1"/>
+          <p:nvPr/>
+        </p:nvSpPr>
+        <p:spPr>
+          <a:xfrm>
+            <a:off x="731520" y="4251960"/>
+            <a:ext cx="2286000" cy="548640"/>
+          </a:xfrm>
+          <a:prstGeom prst="rect">
+            <a:avLst/>
+          </a:prstGeom>
+          <a:noFill/>
+          <a:ln/>
+        </p:spPr>
+        <p:txBody>
+          <a:bodyPr wrap="square" lIns="0" tIns="0" rIns="0" bIns="0" rtlCol="0" anchor="ctr"/>
+          <a:lstStyle/>
+          <a:p>
+            <a:pPr indent="0" marL="0">
+              <a:buNone/>
+            </a:pPr>
+            <a:r>
+              <a:rPr lang="en-US" sz="3000" b="1" dirty="0">
+                <a:solidFill>
+                  <a:srgbClr val="1B2238"/>
+                </a:solidFill>
+              </a:rPr>
+              <a:t>7,8 %</a:t>
+            </a:r>
+            <a:endParaRPr lang="en-US" sz="3000" dirty="0"/>
+          </a:p>
+        </p:txBody>
+      </p:sp>
+      <p:sp>
+        <p:nvSpPr>
+          <p:cNvPr id="34" name="Text 32"/>
+          <p:cNvSpPr txBox="1"/>
+          <p:nvPr/>
+        </p:nvSpPr>
+        <p:spPr>
+          <a:xfrm>
+            <a:off x="731520" y="4846320"/>
+            <a:ext cx="2286000" cy="320040"/>
+          </a:xfrm>
+          <a:prstGeom prst="rect">
+            <a:avLst/>
+          </a:prstGeom>
+          <a:noFill/>
+          <a:ln/>
+        </p:spPr>
+        <p:txBody>
+          <a:bodyPr wrap="square" lIns="0" tIns="0" rIns="0" bIns="0" rtlCol="0" anchor="ctr"/>
+          <a:lstStyle/>
+          <a:p>
+            <a:pPr indent="0" marL="0">
+              <a:buNone/>
+            </a:pPr>
+            <a:r>
+              <a:rPr lang="en-US" sz="1200" b="1" dirty="0">
+                <a:solidFill>
+                  <a:srgbClr val="2E9E6B"/>
+                </a:solidFill>
+              </a:rPr>
+              <a:t>▲ +2,5 pts  vs 23/09 → 30/09</a:t>
+            </a:r>
+            <a:endParaRPr lang="en-US" sz="1200" dirty="0"/>
+          </a:p>
+        </p:txBody>
+      </p:sp>
+      <p:sp>
+        <p:nvSpPr>
+          <p:cNvPr id="35" name="Shape 33"/>
+          <p:cNvSpPr/>
+          <p:nvPr/>
+        </p:nvSpPr>
+        <p:spPr>
+          <a:xfrm>
+            <a:off x="3353105" y="3886200"/>
+            <a:ext cx="2651760" cy="1417320"/>
+          </a:xfrm>
+          <a:prstGeom prst="roundRect">
+            <a:avLst>
+              <a:gd name="adj" fmla="val 6452"/>
+            </a:avLst>
+          </a:prstGeom>
+          <a:solidFill>
+            <a:srgbClr val="F2F4F8"/>
+          </a:solidFill>
+          <a:ln w="12700">
+            <a:solidFill>
+              <a:srgbClr val="F2F4F8"/>
+            </a:solidFill>
+            <a:prstDash val="solid"/>
+          </a:ln>
+        </p:spPr>
+      </p:sp>
+      <p:sp>
+        <p:nvSpPr>
           <p:cNvPr id="36" name="Text 34"/>
           <p:cNvSpPr txBox="1"/>
           <p:nvPr/>
         </p:nvSpPr>
         <p:spPr>
           <a:xfrm>
+            <a:off x="3535985" y="3977640"/>
+            <a:ext cx="2286000" cy="274320"/>
+          </a:xfrm>
+          <a:prstGeom prst="rect">
+            <a:avLst/>
+          </a:prstGeom>
+          <a:noFill/>
+          <a:ln/>
+        </p:spPr>
+        <p:txBody>
+          <a:bodyPr wrap="square" lIns="0" tIns="0" rIns="0" bIns="0" rtlCol="0" anchor="ctr"/>
+          <a:lstStyle/>
+          <a:p>
+            <a:pPr indent="0" marL="0">
+              <a:buNone/>
+            </a:pPr>
+            <a:r>
+              <a:rPr lang="en-US" sz="1100" b="1" dirty="0">
+                <a:solidFill>
+                  <a:srgbClr val="5A6275"/>
+                </a:solidFill>
+              </a:rPr>
+              <a:t>SHARE OF VOICE GEA (ADS)</a:t>
+            </a:r>
+            <a:endParaRPr lang="en-US" sz="1100" dirty="0"/>
+          </a:p>
+        </p:txBody>
+      </p:sp>
+      <p:sp>
+        <p:nvSpPr>
+          <p:cNvPr id="37" name="Text 35"/>
+          <p:cNvSpPr txBox="1"/>
+          <p:nvPr/>
+        </p:nvSpPr>
+        <p:spPr>
+          <a:xfrm>
+            <a:off x="3535985" y="4251960"/>
+            <a:ext cx="2286000" cy="548640"/>
+          </a:xfrm>
+          <a:prstGeom prst="rect">
+            <a:avLst/>
+          </a:prstGeom>
+          <a:noFill/>
+          <a:ln/>
+        </p:spPr>
+        <p:txBody>
+          <a:bodyPr wrap="square" lIns="0" tIns="0" rIns="0" bIns="0" rtlCol="0" anchor="ctr"/>
+          <a:lstStyle/>
+          <a:p>
+            <a:pPr indent="0" marL="0">
+              <a:buNone/>
+            </a:pPr>
+            <a:r>
+              <a:rPr lang="en-US" sz="3000" b="1" dirty="0">
+                <a:solidFill>
+                  <a:srgbClr val="1B2238"/>
+                </a:solidFill>
+              </a:rPr>
+              <a:t>20,2 %</a:t>
+            </a:r>
+            <a:endParaRPr lang="en-US" sz="3000" dirty="0"/>
+          </a:p>
+        </p:txBody>
+      </p:sp>
+      <p:sp>
+        <p:nvSpPr>
+          <p:cNvPr id="38" name="Text 36"/>
+          <p:cNvSpPr txBox="1"/>
+          <p:nvPr/>
+        </p:nvSpPr>
+        <p:spPr>
+          <a:xfrm>
+            <a:off x="3535985" y="4846320"/>
+            <a:ext cx="2286000" cy="320040"/>
+          </a:xfrm>
+          <a:prstGeom prst="rect">
+            <a:avLst/>
+          </a:prstGeom>
+          <a:noFill/>
+          <a:ln/>
+        </p:spPr>
+        <p:txBody>
+          <a:bodyPr wrap="square" lIns="0" tIns="0" rIns="0" bIns="0" rtlCol="0" anchor="ctr"/>
+          <a:lstStyle/>
+          <a:p>
+            <a:pPr indent="0" marL="0">
+              <a:buNone/>
+            </a:pPr>
+            <a:r>
+              <a:rPr lang="en-US" sz="1200" b="1" dirty="0">
+                <a:solidFill>
+                  <a:srgbClr val="C8372D"/>
+                </a:solidFill>
+              </a:rPr>
+              <a:t>▼ -2,8 pts  vs 23/09 → 30/09</a:t>
+            </a:r>
+            <a:endParaRPr lang="en-US" sz="1200" dirty="0"/>
+          </a:p>
+        </p:txBody>
+      </p:sp>
+      <p:sp>
+        <p:nvSpPr>
+          <p:cNvPr id="39" name="Shape 37"/>
+          <p:cNvSpPr/>
+          <p:nvPr/>
+        </p:nvSpPr>
+        <p:spPr>
+          <a:xfrm>
+            <a:off x="6157570" y="3886200"/>
+            <a:ext cx="2651760" cy="1417320"/>
+          </a:xfrm>
+          <a:prstGeom prst="roundRect">
+            <a:avLst>
+              <a:gd name="adj" fmla="val 6452"/>
+            </a:avLst>
+          </a:prstGeom>
+          <a:solidFill>
+            <a:srgbClr val="F2F4F8"/>
+          </a:solidFill>
+          <a:ln w="12700">
+            <a:solidFill>
+              <a:srgbClr val="F2F4F8"/>
+            </a:solidFill>
+            <a:prstDash val="solid"/>
+          </a:ln>
+        </p:spPr>
+      </p:sp>
+      <p:sp>
+        <p:nvSpPr>
+          <p:cNvPr id="40" name="Text 38"/>
+          <p:cNvSpPr txBox="1"/>
+          <p:nvPr/>
+        </p:nvSpPr>
+        <p:spPr>
+          <a:xfrm>
+            <a:off x="6340450" y="3977640"/>
+            <a:ext cx="2286000" cy="274320"/>
+          </a:xfrm>
+          <a:prstGeom prst="rect">
+            <a:avLst/>
+          </a:prstGeom>
+          <a:noFill/>
+          <a:ln/>
+        </p:spPr>
+        <p:txBody>
+          <a:bodyPr wrap="square" lIns="0" tIns="0" rIns="0" bIns="0" rtlCol="0" anchor="ctr"/>
+          <a:lstStyle/>
+          <a:p>
+            <a:pPr indent="0" marL="0">
+              <a:buNone/>
+            </a:pPr>
+            <a:r>
+              <a:rPr lang="en-US" sz="1100" b="1" dirty="0">
+                <a:solidFill>
+                  <a:srgbClr val="5A6275"/>
+                </a:solidFill>
+              </a:rPr>
+              <a:t>SHARE OF VOICE</a:t>
+            </a:r>
+            <a:endParaRPr lang="en-US" sz="1100" dirty="0"/>
+          </a:p>
+        </p:txBody>
+      </p:sp>
+      <p:sp>
+        <p:nvSpPr>
+          <p:cNvPr id="41" name="Text 39"/>
+          <p:cNvSpPr txBox="1"/>
+          <p:nvPr/>
+        </p:nvSpPr>
+        <p:spPr>
+          <a:xfrm>
+            <a:off x="6340450" y="4251960"/>
+            <a:ext cx="2286000" cy="548640"/>
+          </a:xfrm>
+          <a:prstGeom prst="rect">
+            <a:avLst/>
+          </a:prstGeom>
+          <a:noFill/>
+          <a:ln/>
+        </p:spPr>
+        <p:txBody>
+          <a:bodyPr wrap="square" lIns="0" tIns="0" rIns="0" bIns="0" rtlCol="0" anchor="ctr"/>
+          <a:lstStyle/>
+          <a:p>
+            <a:pPr indent="0" marL="0">
+              <a:buNone/>
+            </a:pPr>
+            <a:r>
+              <a:rPr lang="en-US" sz="3000" b="1" dirty="0">
+                <a:solidFill>
+                  <a:srgbClr val="1B2238"/>
+                </a:solidFill>
+              </a:rPr>
+              <a:t>4,3 %</a:t>
+            </a:r>
+            <a:endParaRPr lang="en-US" sz="3000" dirty="0"/>
+          </a:p>
+        </p:txBody>
+      </p:sp>
+      <p:sp>
+        <p:nvSpPr>
+          <p:cNvPr id="42" name="Text 40"/>
+          <p:cNvSpPr txBox="1"/>
+          <p:nvPr/>
+        </p:nvSpPr>
+        <p:spPr>
+          <a:xfrm>
+            <a:off x="6340450" y="4846320"/>
+            <a:ext cx="2286000" cy="320040"/>
+          </a:xfrm>
+          <a:prstGeom prst="rect">
+            <a:avLst/>
+          </a:prstGeom>
+          <a:noFill/>
+          <a:ln/>
+        </p:spPr>
+        <p:txBody>
+          <a:bodyPr wrap="square" lIns="0" tIns="0" rIns="0" bIns="0" rtlCol="0" anchor="ctr"/>
+          <a:lstStyle/>
+          <a:p>
+            <a:pPr indent="0" marL="0">
+              <a:buNone/>
+            </a:pPr>
+            <a:r>
+              <a:rPr lang="en-US" sz="1200" b="1" dirty="0">
+                <a:solidFill>
+                  <a:srgbClr val="2E9E6B"/>
+                </a:solidFill>
+              </a:rPr>
+              <a:t>▲ +0,3 pt  vs 23/09 → 30/09</a:t>
+            </a:r>
+            <a:endParaRPr lang="en-US" sz="1200" dirty="0"/>
+          </a:p>
+        </p:txBody>
+      </p:sp>
+      <p:sp>
+        <p:nvSpPr>
+          <p:cNvPr id="43" name="Shape 41"/>
+          <p:cNvSpPr/>
+          <p:nvPr/>
+        </p:nvSpPr>
+        <p:spPr>
+          <a:xfrm>
+            <a:off x="8962034" y="3886200"/>
+            <a:ext cx="2651760" cy="1417320"/>
+          </a:xfrm>
+          <a:prstGeom prst="roundRect">
+            <a:avLst>
+              <a:gd name="adj" fmla="val 6452"/>
+            </a:avLst>
+          </a:prstGeom>
+          <a:solidFill>
+            <a:srgbClr val="F2F4F8"/>
+          </a:solidFill>
+          <a:ln w="12700">
+            <a:solidFill>
+              <a:srgbClr val="F2F4F8"/>
+            </a:solidFill>
+            <a:prstDash val="solid"/>
+          </a:ln>
+        </p:spPr>
+      </p:sp>
+      <p:sp>
+        <p:nvSpPr>
+          <p:cNvPr id="44" name="Text 42"/>
+          <p:cNvSpPr txBox="1"/>
+          <p:nvPr/>
+        </p:nvSpPr>
+        <p:spPr>
+          <a:xfrm>
+            <a:off x="9144914" y="3977640"/>
+            <a:ext cx="2286000" cy="274320"/>
+          </a:xfrm>
+          <a:prstGeom prst="rect">
+            <a:avLst/>
+          </a:prstGeom>
+          <a:noFill/>
+          <a:ln/>
+        </p:spPr>
+        <p:txBody>
+          <a:bodyPr wrap="square" lIns="0" tIns="0" rIns="0" bIns="0" rtlCol="0" anchor="ctr"/>
+          <a:lstStyle/>
+          <a:p>
+            <a:pPr indent="0" marL="0">
+              <a:buNone/>
+            </a:pPr>
+            <a:r>
+              <a:rPr lang="en-US" sz="1100" b="1" dirty="0">
+                <a:solidFill>
+                  <a:srgbClr val="5A6275"/>
+                </a:solidFill>
+              </a:rPr>
+              <a:t>LONGUEUR DES REQUÊTES</a:t>
+            </a:r>
+            <a:endParaRPr lang="en-US" sz="1100" dirty="0"/>
+          </a:p>
+        </p:txBody>
+      </p:sp>
+      <p:sp>
+        <p:nvSpPr>
+          <p:cNvPr id="45" name="Text 43"/>
+          <p:cNvSpPr txBox="1"/>
+          <p:nvPr/>
+        </p:nvSpPr>
+        <p:spPr>
+          <a:xfrm>
+            <a:off x="9144914" y="4251960"/>
+            <a:ext cx="2286000" cy="548640"/>
+          </a:xfrm>
+          <a:prstGeom prst="rect">
+            <a:avLst/>
+          </a:prstGeom>
+          <a:noFill/>
+          <a:ln/>
+        </p:spPr>
+        <p:txBody>
+          <a:bodyPr wrap="square" lIns="0" tIns="0" rIns="0" bIns="0" rtlCol="0" anchor="ctr"/>
+          <a:lstStyle/>
+          <a:p>
+            <a:pPr indent="0" marL="0">
+              <a:buNone/>
+            </a:pPr>
+            <a:r>
+              <a:rPr lang="en-US" sz="3000" b="1" dirty="0">
+                <a:solidFill>
+                  <a:srgbClr val="1B2238"/>
+                </a:solidFill>
+              </a:rPr>
+              <a:t>8,2 mots</a:t>
+            </a:r>
+            <a:endParaRPr lang="en-US" sz="3000" dirty="0"/>
+          </a:p>
+        </p:txBody>
+      </p:sp>
+      <p:sp>
+        <p:nvSpPr>
+          <p:cNvPr id="46" name="Text 44"/>
+          <p:cNvSpPr txBox="1"/>
+          <p:nvPr/>
+        </p:nvSpPr>
+        <p:spPr>
+          <a:xfrm>
+            <a:off x="9144914" y="4846320"/>
+            <a:ext cx="2286000" cy="320040"/>
+          </a:xfrm>
+          <a:prstGeom prst="rect">
+            <a:avLst/>
+          </a:prstGeom>
+          <a:noFill/>
+          <a:ln/>
+        </p:spPr>
+        <p:txBody>
+          <a:bodyPr wrap="square" lIns="0" tIns="0" rIns="0" bIns="0" rtlCol="0" anchor="ctr"/>
+          <a:lstStyle/>
+          <a:p>
+            <a:pPr indent="0" marL="0">
+              <a:buNone/>
+            </a:pPr>
+            <a:r>
+              <a:rPr lang="en-US" sz="1200" b="1" dirty="0">
+                <a:solidFill>
+                  <a:srgbClr val="2E9E6B"/>
+                </a:solidFill>
+              </a:rPr>
+              <a:t>▲ +10,6 %  vs 23/09 → 30/09</a:t>
+            </a:r>
+            <a:endParaRPr lang="en-US" sz="1200" dirty="0"/>
+          </a:p>
+        </p:txBody>
+      </p:sp>
+      <p:sp>
+        <p:nvSpPr>
+          <p:cNvPr id="47" name="Shape 45"/>
+          <p:cNvSpPr/>
+          <p:nvPr/>
+        </p:nvSpPr>
+        <p:spPr>
+          <a:xfrm>
+            <a:off x="548640" y="5486400"/>
+            <a:ext cx="11064240" cy="566928"/>
+          </a:xfrm>
+          <a:prstGeom prst="roundRect">
+            <a:avLst>
+              <a:gd name="adj" fmla="val 12903"/>
+            </a:avLst>
+          </a:prstGeom>
+          <a:solidFill>
+            <a:srgbClr val="F2F4F8"/>
+          </a:solidFill>
+          <a:ln w="12700">
+            <a:solidFill>
+              <a:srgbClr val="F2F4F8"/>
+            </a:solidFill>
+            <a:prstDash val="solid"/>
+          </a:ln>
+        </p:spPr>
+      </p:sp>
+      <p:sp>
+        <p:nvSpPr>
+          <p:cNvPr id="48" name="Text 46"/>
+          <p:cNvSpPr txBox="1"/>
+          <p:nvPr/>
+        </p:nvSpPr>
+        <p:spPr>
+          <a:xfrm>
             <a:off x="731520" y="5486400"/>
             <a:ext cx="10698480" cy="566928"/>
           </a:xfrm>
@@ -7485,45 +7935,9 @@
                   <a:srgbClr val="1B2238"/>
                 </a:solidFill>
               </a:rPr>
-              <a:t>l'IA recommande davantage Boulanger d'elle-même (+2,5 pts), tandis que la part de voix ads recule de 2,8 pts.</a:t>
+              <a:t>la diffusion progresse (+16,7 %) mais les clics reculent (-11,3 %) et le CPC monte à 0,37 € ; côté IA, Boulanger gagne +2,5 pts de recommandations spontanées.</a:t>
             </a:r>
             <a:endParaRPr lang="en-US" sz="1400" dirty="0"/>
-          </a:p>
-        </p:txBody>
-      </p:sp>
-      <p:sp>
-        <p:nvSpPr>
-          <p:cNvPr id="37" name="Text 35"/>
-          <p:cNvSpPr txBox="1"/>
-          <p:nvPr/>
-        </p:nvSpPr>
-        <p:spPr>
-          <a:xfrm>
-            <a:off x="548640" y="6080760"/>
-            <a:ext cx="10972800" cy="274320"/>
-          </a:xfrm>
-          <a:prstGeom prst="rect">
-            <a:avLst/>
-          </a:prstGeom>
-          <a:noFill/>
-          <a:ln/>
-        </p:spPr>
-        <p:txBody>
-          <a:bodyPr wrap="square" lIns="0" tIns="0" rIns="0" bIns="0" rtlCol="0" anchor="ctr"/>
-          <a:lstStyle/>
-          <a:p>
-            <a:pPr indent="0" marL="0">
-              <a:buNone/>
-            </a:pPr>
-            <a:r>
-              <a:rPr lang="en-US" sz="1000" i="1" dirty="0">
-                <a:solidFill>
-                  <a:srgbClr val="5A6275"/>
-                </a:solidFill>
-              </a:rPr>
-              <a:t>Données média hebdomadaires absentes de la source : à compléter depuis l'outil de campagne avant envoi.</a:t>
-            </a:r>
-            <a:endParaRPr lang="en-US" sz="1000" dirty="0"/>
           </a:p>
         </p:txBody>
       </p:sp>
@@ -8283,7 +8697,7 @@
                   <a:srgbClr val="1B2238"/>
                 </a:solidFill>
               </a:rPr>
-              <a:t>cette semaine, la part de voix progresse légèrement (+0,3 pt) ; le trafic qualifié reste à compléter.</a:t>
+              <a:t>cette semaine, la part de voix progresse légèrement (+0,3 pt) mais le trafic qualifié recule de 11,3 %.</a:t>
             </a:r>
             <a:endParaRPr lang="en-US" sz="1400" dirty="0"/>
           </a:p>

</xml_diff>

<commit_message>
Rapport Boulanger 01.10-08.10 : ajout des conversions (GEA Focus)
Co-Authored-By: Claude Opus 5.5 <noreply@anthropic.com>
Claude-Session: https://claude.ai/code/session_018e7SCuQygFSJNrAfjS85j9
</commit_message>
<xml_diff>
--- a/rapports/In progress_20261009_Rapport_Boulanger_Hebdo_01.10-08.10.pptx
+++ b/rapports/In progress_20261009_Rapport_Boulanger_Hebdo_01.10-08.10.pptx
@@ -118,12 +118,12 @@
   <p:extLst>
     <p:ext uri="{521415D9-36F7-43E2-AB2F-B90AF26B5E84}">
       <p14:sectionLst xmlns:p14="http://schemas.microsoft.com/office/powerpoint/2010/main">
-        <p14:section name="Introduction" id="{726c7d39-25ef-cda0-72a2-3e6521105287}">
+        <p14:section name="Introduction" id="{f4ce1934-4f84-f680-d598-103eb16d7940}">
           <p14:sldIdLst>
             <p14:sldId id="256"/>
           </p14:sldIdLst>
         </p14:section>
-        <p14:section name="Boulanger" id="{e66bbf44-c82a-5fd6-9196-6278b7a29ad1}">
+        <p14:section name="Boulanger" id="{de083727-5c6d-3d2e-47b5-93506f89801d}">
           <p14:sldIdLst>
             <p14:sldId id="257"/>
             <p14:sldId id="258"/>
@@ -134,7 +134,7 @@
             <p14:sldId id="263"/>
           </p14:sldIdLst>
         </p14:section>
-        <p14:section name="Pistes de reco" id="{5221ac71-fe45-bc77-d4fd-e9d283f0ac4e}">
+        <p14:section name="Pistes de reco" id="{15fda0d3-ec80-ff5a-a427-77ba43be44db}">
           <p14:sldIdLst>
             <p14:sldId id="264"/>
             <p14:sldId id="265"/>
@@ -6319,7 +6319,7 @@
                   <a:schemeClr val="tx1"/>
                 </a:solidFill>
               </a:rPr>
-              <a:t>Plus de diffusion, moins de clics, des clics plus chers</a:t>
+              <a:t>Moins de clics, mais deux fois plus de ventes</a:t>
             </a:r>
             <a:endParaRPr lang="en-US" sz="3000" dirty="0"/>
           </a:p>
@@ -6391,7 +6391,7 @@
                   <a:srgbClr val="E8601C"/>
                 </a:solidFill>
               </a:rPr>
-              <a:t>PERFORMANCE MÉDIA · BUDGET CONSOMMÉ 7 279,90 € sur 30 000 € · 24 %</a:t>
+              <a:t>PERFORMANCE MÉDIA · BUDGET SEMAINE 2 367,15 € · CUMUL 7 279,90 € sur 30 000 € (24 %) · CA HT 888,68 €</a:t>
             </a:r>
             <a:endParaRPr lang="en-US" sz="1200" dirty="0"/>
           </a:p>
@@ -7086,7 +7086,7 @@
                   <a:srgbClr val="1B2238"/>
                 </a:solidFill>
               </a:rPr>
-              <a:t>n. d.</a:t>
+              <a:t>6</a:t>
             </a:r>
             <a:endParaRPr lang="en-US" sz="2000" dirty="0"/>
           </a:p>
@@ -7119,24 +7119,24 @@
             <a:r>
               <a:rPr lang="en-US" sz="1000" b="1" dirty="0">
                 <a:solidFill>
+                  <a:srgbClr val="2E9E6B"/>
+                </a:solidFill>
+              </a:rPr>
+              <a:t>▲ +100 % (3)</a:t>
+            </a:r>
+            <a:endParaRPr lang="en-US" sz="1000" dirty="0"/>
+          </a:p>
+          <a:p>
+            <a:pPr indent="0" marL="0">
+              <a:buNone/>
+            </a:pPr>
+            <a:r>
+              <a:rPr lang="en-US" sz="1000" dirty="0">
+                <a:solidFill>
                   <a:srgbClr val="5A6275"/>
                 </a:solidFill>
               </a:rPr>
-              <a:t>—</a:t>
-            </a:r>
-            <a:endParaRPr lang="en-US" sz="1000" dirty="0"/>
-          </a:p>
-          <a:p>
-            <a:pPr indent="0" marL="0">
-              <a:buNone/>
-            </a:pPr>
-            <a:r>
-              <a:rPr lang="en-US" sz="1000" dirty="0">
-                <a:solidFill>
-                  <a:srgbClr val="5A6275"/>
-                </a:solidFill>
-              </a:rPr>
-              <a:t>Tracker en cours</a:t>
+              <a:t>YTD 15</a:t>
             </a:r>
             <a:endParaRPr lang="en-US" sz="1000" dirty="0"/>
           </a:p>
@@ -7235,7 +7235,7 @@
                   <a:srgbClr val="1B2238"/>
                 </a:solidFill>
               </a:rPr>
-              <a:t>n. d.</a:t>
+              <a:t>0,29 %</a:t>
             </a:r>
             <a:endParaRPr lang="en-US" sz="2000" dirty="0"/>
           </a:p>
@@ -7268,24 +7268,24 @@
             <a:r>
               <a:rPr lang="en-US" sz="1000" b="1" dirty="0">
                 <a:solidFill>
+                  <a:srgbClr val="2E9E6B"/>
+                </a:solidFill>
+              </a:rPr>
+              <a:t>▲ +0,17 pt</a:t>
+            </a:r>
+            <a:endParaRPr lang="en-US" sz="1000" dirty="0"/>
+          </a:p>
+          <a:p>
+            <a:pPr indent="0" marL="0">
+              <a:buNone/>
+            </a:pPr>
+            <a:r>
+              <a:rPr lang="en-US" sz="1000" dirty="0">
+                <a:solidFill>
                   <a:srgbClr val="5A6275"/>
                 </a:solidFill>
               </a:rPr>
-              <a:t>—</a:t>
-            </a:r>
-            <a:endParaRPr lang="en-US" sz="1000" dirty="0"/>
-          </a:p>
-          <a:p>
-            <a:pPr indent="0" marL="0">
-              <a:buNone/>
-            </a:pPr>
-            <a:r>
-              <a:rPr lang="en-US" sz="1000" dirty="0">
-                <a:solidFill>
-                  <a:srgbClr val="5A6275"/>
-                </a:solidFill>
-              </a:rPr>
-              <a:t>Tracker en cours</a:t>
+              <a:t>YTD 0,20 %</a:t>
             </a:r>
             <a:endParaRPr lang="en-US" sz="1000" dirty="0"/>
           </a:p>
@@ -7935,7 +7935,7 @@
                   <a:srgbClr val="1B2238"/>
                 </a:solidFill>
               </a:rPr>
-              <a:t>la diffusion progresse (+16,7 %) mais les clics reculent (-11,3 %) et le CPC monte à 0,37 € ; côté IA, Boulanger gagne +2,5 pts de recommandations spontanées.</a:t>
+              <a:t>les conversions doublent (6 ventes, 888,68 € HT, CVR 0,29 %) malgré des clics en recul (-11,3 %) et un CPC à 0,37 €.</a:t>
             </a:r>
             <a:endParaRPr lang="en-US" sz="1400" dirty="0"/>
           </a:p>
@@ -8623,7 +8623,7 @@
                   <a:srgbClr val="5A6275"/>
                 </a:solidFill>
               </a:rPr>
-              <a:t>Ventes attribuées aux clics IA (tracker en déploiement).</a:t>
+              <a:t>Ventes attribuées aux clics IA : 6 cette semaine.</a:t>
             </a:r>
             <a:endParaRPr lang="en-US" sz="1400" dirty="0"/>
           </a:p>
@@ -12833,7 +12833,7 @@
                   <a:schemeClr val="tx1"/>
                 </a:solidFill>
               </a:rPr>
-              <a:t>Finaliser le conversion tracker</a:t>
+              <a:t>Fiabiliser la mesure des conversions</a:t>
             </a:r>
             <a:endParaRPr lang="en-US" sz="3000" dirty="0"/>
           </a:p>
@@ -12869,7 +12869,7 @@
                   <a:srgbClr val="5A6275"/>
                 </a:solidFill>
               </a:rPr>
-              <a:t>L'implémentation a démarré chez vous le 1er octobre. Statut à mettre à jour avant envoi.</a:t>
+              <a:t>Les premières ventes remontent : 15 transactions et 2 103 € HT depuis le lancement, dont 6 cette semaine.</a:t>
             </a:r>
             <a:endParaRPr lang="en-US" sz="1400" dirty="0"/>
           </a:p>
@@ -12935,7 +12935,7 @@
                   <a:srgbClr val="E8601C"/>
                 </a:solidFill>
               </a:rPr>
-              <a:t>Où nous en sommes</a:t>
+              <a:t>Ce que disent les chiffres</a:t>
             </a:r>
             <a:endParaRPr lang="en-US" sz="1600" dirty="0"/>
           </a:p>
@@ -12953,7 +12953,7 @@
                   <a:srgbClr val="1B2238"/>
                 </a:solidFill>
               </a:rPr>
-              <a:t>Pixel et guide GTM transmis le 28 septembre.</a:t>
+              <a:t>1–8 oct. : 6 transactions, 888,68 € HT, panier moyen 148 €.</a:t>
             </a:r>
             <a:endParaRPr lang="en-US" sz="1600" dirty="0"/>
           </a:p>
@@ -12971,7 +12971,7 @@
                   <a:srgbClr val="1B2238"/>
                 </a:solidFill>
               </a:rPr>
-              <a:t>Intégration lancée par Fadi le 1er octobre.</a:t>
+              <a:t>6 sur 6 réalisées par de nouveaux clients.</a:t>
             </a:r>
             <a:endParaRPr lang="en-US" sz="1600" dirty="0"/>
           </a:p>
@@ -12989,7 +12989,7 @@
                   <a:srgbClr val="1B2238"/>
                 </a:solidFill>
               </a:rPr>
-              <a:t>Choix template GTM / script serveur : à confirmer.</a:t>
+              <a:t>CVR 0,29 % sur 2 039 visites (0,12 % la semaine précédente).</a:t>
             </a:r>
             <a:endParaRPr lang="en-US" sz="1600" dirty="0"/>
           </a:p>
@@ -13055,7 +13055,7 @@
                   <a:srgbClr val="E8601C"/>
                 </a:solidFill>
               </a:rPr>
-              <a:t>Les deux points à lever</a:t>
+              <a:t>Les points à lever</a:t>
             </a:r>
             <a:endParaRPr lang="en-US" sz="1600" dirty="0"/>
           </a:p>
@@ -13073,7 +13073,7 @@
                   <a:srgbClr val="1B2238"/>
                 </a:solidFill>
               </a:rPr>
-              <a:t>Consentement Didomi : ajouter Lemrock comme vendor personnalisé (finalités 1 et 7).</a:t>
+              <a:t>Écart clics / visites : 6 468 clics Lemrock pour 2 039 visites mesurées (31 %).</a:t>
             </a:r>
             <a:endParaRPr lang="en-US" sz="1600" dirty="0"/>
           </a:p>
@@ -13091,7 +13091,25 @@
                   <a:srgbClr val="1B2238"/>
                 </a:solidFill>
               </a:rPr>
-              <a:t>Paramètre at_medium : correction du « ? » manquant côté Lemrock.</a:t>
+              <a:t>Paramètre at_medium et consentement Didomi : à finaliser pour réduire cet écart.</a:t>
+            </a:r>
+            <a:endParaRPr lang="en-US" sz="1600" dirty="0"/>
+          </a:p>
+          <a:p>
+            <a:pPr marL="342900" indent="-342900">
+              <a:spcAft>
+                <a:spcPts val="800"/>
+              </a:spcAft>
+              <a:buSzPct val="100000"/>
+              <a:buChar char="•"/>
+            </a:pPr>
+            <a:r>
+              <a:rPr lang="en-US" sz="1400" dirty="0">
+                <a:solidFill>
+                  <a:srgbClr val="1B2238"/>
+                </a:solidFill>
+              </a:rPr>
+              <a:t>ROAS de la semaine : 0,38 (CA HT / budget).</a:t>
             </a:r>
             <a:endParaRPr lang="en-US" sz="1600" dirty="0"/>
           </a:p>
@@ -13165,7 +13183,7 @@
                   <a:srgbClr val="1B2238"/>
                 </a:solidFill>
               </a:rPr>
-              <a:t>valider ensemble la remontée des données pour afficher Conversions et CVR dès le prochain rapport.</a:t>
+              <a:t>réconcilier clics et visites avec vos équipes pour que chaque vente attribuée à Lemrock soit comptée.</a:t>
             </a:r>
             <a:endParaRPr lang="en-US" sz="1400" dirty="0"/>
           </a:p>

</xml_diff>

<commit_message>
Rapport Boulanger 01.10-08.10 : ajout du champ sémantique des conversations
Co-Authored-By: Claude Opus 5.5 <noreply@anthropic.com>
Claude-Session: https://claude.ai/code/session_018e7SCuQygFSJNrAfjS85j9
</commit_message>
<xml_diff>
--- a/rapports/In progress_20261009_Rapport_Boulanger_Hebdo_01.10-08.10.pptx
+++ b/rapports/In progress_20261009_Rapport_Boulanger_Hebdo_01.10-08.10.pptx
@@ -17,9 +17,10 @@
     <p:sldId id="265" r:id="rId11"/>
     <p:sldId id="266" r:id="rId12"/>
     <p:sldId id="267" r:id="rId13"/>
+    <p:sldId id="268" r:id="rId14"/>
   </p:sldIdLst>
   <p:notesMasterIdLst>
-    <p:notesMasterId r:id="rId14"/>
+    <p:notesMasterId r:id="rId15"/>
   </p:notesMasterIdLst>
   <p:sldSz cx="12192000" cy="6858000"/>
   <p:notesSz cx="6858000" cy="12192000"/>
@@ -118,12 +119,12 @@
   <p:extLst>
     <p:ext uri="{521415D9-36F7-43E2-AB2F-B90AF26B5E84}">
       <p14:sectionLst xmlns:p14="http://schemas.microsoft.com/office/powerpoint/2010/main">
-        <p14:section name="Introduction" id="{f4ce1934-4f84-f680-d598-103eb16d7940}">
+        <p14:section name="Introduction" id="{673ec8b9-c386-070f-0962-b594f2b5ff58}">
           <p14:sldIdLst>
             <p14:sldId id="256"/>
           </p14:sldIdLst>
         </p14:section>
-        <p14:section name="Boulanger" id="{de083727-5c6d-3d2e-47b5-93506f89801d}">
+        <p14:section name="Boulanger" id="{38c507cc-3f94-4d71-3d51-56572417def4}">
           <p14:sldIdLst>
             <p14:sldId id="257"/>
             <p14:sldId id="258"/>
@@ -132,14 +133,15 @@
             <p14:sldId id="261"/>
             <p14:sldId id="262"/>
             <p14:sldId id="263"/>
+            <p14:sldId id="264"/>
           </p14:sldIdLst>
         </p14:section>
-        <p14:section name="Pistes de reco" id="{15fda0d3-ec80-ff5a-a427-77ba43be44db}">
+        <p14:section name="Pistes de reco" id="{7d49d753-d0c6-771f-a765-36cb67ffde03}">
           <p14:sldIdLst>
-            <p14:sldId id="264"/>
             <p14:sldId id="265"/>
             <p14:sldId id="266"/>
             <p14:sldId id="267"/>
+            <p14:sldId id="268"/>
           </p14:sldIdLst>
         </p14:section>
       </p14:sectionLst>
@@ -2524,6 +2526,94 @@
 </p:notes>
 </file>
 
+<file path=ppt/notesSlides/notesSlide13.xml><?xml version="1.0" encoding="utf-8"?>
+<p:notes xmlns:a="http://schemas.openxmlformats.org/drawingml/2006/main" xmlns:r="http://schemas.openxmlformats.org/officeDocument/2006/relationships" xmlns:p="http://schemas.openxmlformats.org/presentationml/2006/main">
+  <p:cSld>
+    <p:spTree>
+      <p:nvGrpSpPr>
+        <p:cNvPr id="1" name=""/>
+        <p:cNvGrpSpPr/>
+        <p:nvPr/>
+      </p:nvGrpSpPr>
+      <p:grpSpPr>
+        <a:xfrm>
+          <a:off x="0" y="0"/>
+          <a:ext cx="0" cy="0"/>
+          <a:chOff x="0" y="0"/>
+          <a:chExt cx="0" cy="0"/>
+        </a:xfrm>
+      </p:grpSpPr>
+      <p:sp>
+        <p:nvSpPr>
+          <p:cNvPr id="2" name="Slide Image Placeholder 1"/>
+          <p:cNvSpPr>
+            <a:spLocks noGrp="1" noRot="1" noChangeAspect="1"/>
+          </p:cNvSpPr>
+          <p:nvPr>
+            <p:ph type="sldImg"/>
+          </p:nvPr>
+        </p:nvSpPr>
+        <p:spPr/>
+      </p:sp>
+      <p:sp>
+        <p:nvSpPr>
+          <p:cNvPr id="3" name="Notes Placeholder 2"/>
+          <p:cNvSpPr>
+            <a:spLocks noGrp="1"/>
+          </p:cNvSpPr>
+          <p:nvPr>
+            <p:ph type="body" idx="1"/>
+          </p:nvPr>
+        </p:nvSpPr>
+        <p:spPr/>
+        <p:txBody>
+          <a:bodyPr/>
+          <a:lstStyle/>
+          <a:p>
+            <a:r>
+              <a:rPr lang="en-US" dirty="0"/>
+              <a:t/>
+            </a:r>
+            <a:endParaRPr lang="en-US" dirty="0"/>
+          </a:p>
+        </p:txBody>
+      </p:sp>
+      <p:sp>
+        <p:nvSpPr>
+          <p:cNvPr id="4" name="Slide Number Placeholder 3"/>
+          <p:cNvSpPr>
+            <a:spLocks noGrp="1"/>
+          </p:cNvSpPr>
+          <p:nvPr>
+            <p:ph type="sldNum" sz="quarter" idx="10"/>
+          </p:nvPr>
+        </p:nvSpPr>
+        <p:spPr/>
+        <p:txBody>
+          <a:bodyPr/>
+          <a:lstStyle/>
+          <a:p>
+            <a:fld id="{F7021451-1387-4CA6-816F-3879F97B5CBC}" type="slidenum">
+              <a:rPr lang="en-US"/>
+              <a:t>13</a:t>
+            </a:fld>
+            <a:endParaRPr lang="en-US"/>
+          </a:p>
+        </p:txBody>
+      </p:sp>
+    </p:spTree>
+    <p:extLst>
+      <p:ext uri="{BB962C8B-B14F-4D97-AF65-F5344CB8AC3E}">
+        <p14:creationId xmlns:p14="http://schemas.microsoft.com/office/powerpoint/2010/main" val="1024086991"/>
+      </p:ext>
+    </p:extLst>
+  </p:cSld>
+  <p:clrMapOvr>
+    <a:masterClrMapping/>
+  </p:clrMapOvr>
+</p:notes>
+</file>
+
 <file path=ppt/notesSlides/notesSlide2.xml><?xml version="1.0" encoding="utf-8"?>
 <p:notes xmlns:a="http://schemas.openxmlformats.org/drawingml/2006/main" xmlns:r="http://schemas.openxmlformats.org/officeDocument/2006/relationships" xmlns:p="http://schemas.openxmlformats.org/presentationml/2006/main">
   <p:cSld>
@@ -4201,7 +4291,7 @@
                   <a:schemeClr val="tx1"/>
                 </a:solidFill>
               </a:rPr>
-              <a:t>Faire du smartphone votre priorité de visibilité</a:t>
+              <a:t>Fiabiliser la mesure des conversions</a:t>
             </a:r>
             <a:endParaRPr lang="en-US" sz="3000" dirty="0"/>
           </a:p>
@@ -4237,7 +4327,7 @@
                   <a:srgbClr val="5A6275"/>
                 </a:solidFill>
               </a:rPr>
-              <a:t>La semaine confirme la priorité exprimée pour 2027 : la demande smartphone progresse.</a:t>
+              <a:t>Les premières ventes remontent : 15 transactions et 2 103 € HT depuis le lancement, dont 6 cette semaine.</a:t>
             </a:r>
             <a:endParaRPr lang="en-US" sz="1400" dirty="0"/>
           </a:p>
@@ -4321,7 +4411,7 @@
                   <a:srgbClr val="1B2238"/>
                 </a:solidFill>
               </a:rPr>
-              <a:t>Téléphones mobiles : 1re catégorie, 10,4 % des conversations (6,1 % au rapport précédent, mesure par intention).</a:t>
+              <a:t>1–8 oct. : 6 transactions, 888,68 € HT, panier moyen 148 €.</a:t>
             </a:r>
             <a:endParaRPr lang="en-US" sz="1600" dirty="0"/>
           </a:p>
@@ -4339,7 +4429,7 @@
                   <a:srgbClr val="1B2238"/>
                 </a:solidFill>
               </a:rPr>
-              <a:t>Apple 9,3 %, Samsung 8,4 %, Xiaomi 5,5 %, Google 5,1 %.</a:t>
+              <a:t>6 sur 6 réalisées par de nouveaux clients.</a:t>
             </a:r>
             <a:endParaRPr lang="en-US" sz="1600" dirty="0"/>
           </a:p>
@@ -4357,7 +4447,7 @@
                   <a:srgbClr val="1B2238"/>
                 </a:solidFill>
               </a:rPr>
-              <a:t>Modèles cités : iPhone 17 Pro, Galaxy S25/S26, Redmi Note 15 Pro, Pixel 10a.</a:t>
+              <a:t>CVR 0,29 % sur 2 039 visites (0,12 % la semaine précédente).</a:t>
             </a:r>
             <a:endParaRPr lang="en-US" sz="1600" dirty="0"/>
           </a:p>
@@ -4423,7 +4513,7 @@
                   <a:srgbClr val="E8601C"/>
                 </a:solidFill>
               </a:rPr>
-              <a:t>Ce que nous proposons</a:t>
+              <a:t>Les points à lever</a:t>
             </a:r>
             <a:endParaRPr lang="en-US" sz="1600" dirty="0"/>
           </a:p>
@@ -4441,7 +4531,7 @@
                   <a:srgbClr val="1B2238"/>
                 </a:solidFill>
               </a:rPr>
-              <a:t>Ad groups dédiés aux modèles les plus nommés.</a:t>
+              <a:t>Écart clics / visites : 6 468 clics Lemrock pour 2 039 visites mesurées (31 %).</a:t>
             </a:r>
             <a:endParaRPr lang="en-US" sz="1600" dirty="0"/>
           </a:p>
@@ -4459,7 +4549,7 @@
                   <a:srgbClr val="1B2238"/>
                 </a:solidFill>
               </a:rPr>
-              <a:t>Mettre en avant le prix : « moins de 200 € », « maxi 250 € » reviennent dans les requêtes.</a:t>
+              <a:t>Paramètre at_medium et consentement Didomi : à finaliser pour réduire cet écart.</a:t>
             </a:r>
             <a:endParaRPr lang="en-US" sz="1600" dirty="0"/>
           </a:p>
@@ -4477,7 +4567,7 @@
                   <a:srgbClr val="1B2238"/>
                 </a:solidFill>
               </a:rPr>
-              <a:t>Plan de visibilité smartphone 2027 : références et budget.</a:t>
+              <a:t>ROAS de la semaine : 0,38 (CA HT / budget).</a:t>
             </a:r>
             <a:endParaRPr lang="en-US" sz="1600" dirty="0"/>
           </a:p>
@@ -4551,7 +4641,7 @@
                   <a:srgbClr val="1B2238"/>
                 </a:solidFill>
               </a:rPr>
-              <a:t>nous construisons avec vous le plan smartphone 2027, ad groups, sélection de références et budget associé.</a:t>
+              <a:t>réconcilier clics et visites avec vos équipes pour que chaque vente attribuée à Lemrock soit comptée.</a:t>
             </a:r>
             <a:endParaRPr lang="en-US" sz="1400" dirty="0"/>
           </a:p>
@@ -4693,7 +4783,7 @@
                   <a:schemeClr val="tx1"/>
                 </a:solidFill>
               </a:rPr>
-              <a:t>Resserrer la sélection de produits poussés</a:t>
+              <a:t>Faire du smartphone votre priorité de visibilité</a:t>
             </a:r>
             <a:endParaRPr lang="en-US" sz="3000" dirty="0"/>
           </a:p>
@@ -4729,7 +4819,7 @@
                   <a:srgbClr val="5A6275"/>
                 </a:solidFill>
               </a:rPr>
-              <a:t>Le prix est le 1er frein (22,0 %) et le 1er critère de choix (10,1 %) : les références poussées doivent y répondre.</a:t>
+              <a:t>La semaine confirme la priorité exprimée pour 2027 : la demande smartphone progresse.</a:t>
             </a:r>
             <a:endParaRPr lang="en-US" sz="1400" dirty="0"/>
           </a:p>
@@ -4813,7 +4903,7 @@
                   <a:srgbClr val="1B2238"/>
                 </a:solidFill>
               </a:rPr>
-              <a:t>Prix trop élevé : 22,0 % des freins, attente promo : 9,1 %.</a:t>
+              <a:t>Téléphones mobiles : 1re catégorie, 10,4 % des conversations (6,1 % au rapport précédent, mesure par intention).</a:t>
             </a:r>
             <a:endParaRPr lang="en-US" sz="1600" dirty="0"/>
           </a:p>
@@ -4831,7 +4921,7 @@
                   <a:srgbClr val="1B2238"/>
                 </a:solidFill>
               </a:rPr>
-              <a:t>CTR en recul de 0,16 pt à 0,49 %, CPC en hausse de 26,6 % à 0,37 €.</a:t>
+              <a:t>Apple 9,3 %, Samsung 8,4 %, Xiaomi 5,5 %, Google 5,1 %.</a:t>
             </a:r>
             <a:endParaRPr lang="en-US" sz="1600" dirty="0"/>
           </a:p>
@@ -4849,7 +4939,7 @@
                   <a:srgbClr val="1B2238"/>
                 </a:solidFill>
               </a:rPr>
-              <a:t>Les requêtes s'allongent : 8,2 mots (+10,6 %).</a:t>
+              <a:t>Modèles cités : iPhone 17 Pro, Galaxy S25/S26, Redmi Note 15 Pro, Pixel 10a.</a:t>
             </a:r>
             <a:endParaRPr lang="en-US" sz="1600" dirty="0"/>
           </a:p>
@@ -4915,7 +5005,7 @@
                   <a:srgbClr val="E8601C"/>
                 </a:solidFill>
               </a:rPr>
-              <a:t>Où commencer</a:t>
+              <a:t>Ce que nous proposons</a:t>
             </a:r>
             <a:endParaRPr lang="en-US" sz="1600" dirty="0"/>
           </a:p>
@@ -4933,7 +5023,7 @@
                   <a:srgbClr val="1B2238"/>
                 </a:solidFill>
               </a:rPr>
-              <a:t>Smartphone · 10,4 %</a:t>
+              <a:t>Ad groups dédiés aux modèles les plus nommés.</a:t>
             </a:r>
             <a:endParaRPr lang="en-US" sz="1600" dirty="0"/>
           </a:p>
@@ -4951,7 +5041,7 @@
                   <a:srgbClr val="1B2238"/>
                 </a:solidFill>
               </a:rPr>
-              <a:t>Enceintes · 6,9 %</a:t>
+              <a:t>Mettre en avant le prix : « moins de 200 € », « maxi 250 € » reviennent dans les requêtes.</a:t>
             </a:r>
             <a:endParaRPr lang="en-US" sz="1600" dirty="0"/>
           </a:p>
@@ -4969,25 +5059,7 @@
                   <a:srgbClr val="1B2238"/>
                 </a:solidFill>
               </a:rPr>
-              <a:t>Casques et écouteurs · 6,7 %</a:t>
-            </a:r>
-            <a:endParaRPr lang="en-US" sz="1600" dirty="0"/>
-          </a:p>
-          <a:p>
-            <a:pPr marL="342900" indent="-342900">
-              <a:spcAft>
-                <a:spcPts val="800"/>
-              </a:spcAft>
-              <a:buSzPct val="100000"/>
-              <a:buChar char="•"/>
-            </a:pPr>
-            <a:r>
-              <a:rPr lang="en-US" sz="1400" dirty="0">
-                <a:solidFill>
-                  <a:srgbClr val="1B2238"/>
-                </a:solidFill>
-              </a:rPr>
-              <a:t>Aspirateurs · 6,0 %</a:t>
+              <a:t>Plan de visibilité smartphone 2027 : références et budget.</a:t>
             </a:r>
             <a:endParaRPr lang="en-US" sz="1600" dirty="0"/>
           </a:p>
@@ -5061,7 +5133,7 @@
                   <a:srgbClr val="1B2238"/>
                 </a:solidFill>
               </a:rPr>
-              <a:t>nous vous proposons une sélection resserrée sur ces quatre catégories, avec des références à bon rapport qualité-prix.</a:t>
+              <a:t>nous construisons avec vous le plan smartphone 2027, ad groups, sélection de références et budget associé.</a:t>
             </a:r>
             <a:endParaRPr lang="en-US" sz="1400" dirty="0"/>
           </a:p>
@@ -5203,7 +5275,7 @@
                   <a:schemeClr val="tx1"/>
                 </a:solidFill>
               </a:rPr>
-              <a:t>Activer Bose, puis packager l'offre</a:t>
+              <a:t>Resserrer la sélection de produits poussés</a:t>
             </a:r>
             <a:endParaRPr lang="en-US" sz="3000" dirty="0"/>
           </a:p>
@@ -5239,7 +5311,7 @@
                   <a:srgbClr val="5A6275"/>
                 </a:solidFill>
               </a:rPr>
-              <a:t>Bose pèse 2,2 % des conversations de la semaine : la demande existe dans vos catégories audio.</a:t>
+              <a:t>Le prix est le 1er frein (22,0 %) et le 1er critère de choix (10,1 %) : les références poussées doivent y répondre.</a:t>
             </a:r>
             <a:endParaRPr lang="en-US" sz="1400" dirty="0"/>
           </a:p>
@@ -5305,7 +5377,7 @@
                   <a:srgbClr val="E8601C"/>
                 </a:solidFill>
               </a:rPr>
-              <a:t>Le dispositif Bose</a:t>
+              <a:t>Ce que disent les chiffres</a:t>
             </a:r>
             <a:endParaRPr lang="en-US" sz="1600" dirty="0"/>
           </a:p>
@@ -5323,7 +5395,7 @@
                   <a:srgbClr val="1B2238"/>
                 </a:solidFill>
               </a:rPr>
-              <a:t>Produits Bose dans les annonces IA, liens vers boulanger.com.</a:t>
+              <a:t>Prix trop élevé : 22,0 % des freins, attente promo : 9,1 %.</a:t>
             </a:r>
             <a:endParaRPr lang="en-US" sz="1600" dirty="0"/>
           </a:p>
@@ -5341,7 +5413,7 @@
                   <a:srgbClr val="1B2238"/>
                 </a:solidFill>
               </a:rPr>
-              <a:t>Campagne distincte du fil rouge, avec ses propres indicateurs.</a:t>
+              <a:t>CTR en recul de 0,16 pt à 0,49 %, CPC en hausse de 26,6 % à 0,37 €.</a:t>
             </a:r>
             <a:endParaRPr lang="en-US" sz="1600" dirty="0"/>
           </a:p>
@@ -5359,7 +5431,7 @@
                   <a:srgbClr val="1B2238"/>
                 </a:solidFill>
               </a:rPr>
-              <a:t>Budget envisagé : 20 000 € / mois (à confirmer).</a:t>
+              <a:t>Les requêtes s'allongent : 8,2 mots (+10,6 %).</a:t>
             </a:r>
             <a:endParaRPr lang="en-US" sz="1600" dirty="0"/>
           </a:p>
@@ -5425,7 +5497,7 @@
                   <a:srgbClr val="E8601C"/>
                 </a:solidFill>
               </a:rPr>
-              <a:t>Le cadre à fixer ensemble</a:t>
+              <a:t>Où commencer</a:t>
             </a:r>
             <a:endParaRPr lang="en-US" sz="1600" dirty="0"/>
           </a:p>
@@ -5443,7 +5515,7 @@
                   <a:srgbClr val="1B2238"/>
                 </a:solidFill>
               </a:rPr>
-              <a:t>Durée du test et critères de validation.</a:t>
+              <a:t>Smartphone · 10,4 %</a:t>
             </a:r>
             <a:endParaRPr lang="en-US" sz="1600" dirty="0"/>
           </a:p>
@@ -5461,7 +5533,7 @@
                   <a:srgbClr val="1B2238"/>
                 </a:solidFill>
               </a:rPr>
-              <a:t>Partage de revenu Boulanger / Lemrock.</a:t>
+              <a:t>Enceintes · 6,9 %</a:t>
             </a:r>
             <a:endParaRPr lang="en-US" sz="1600" dirty="0"/>
           </a:p>
@@ -5479,7 +5551,25 @@
                   <a:srgbClr val="1B2238"/>
                 </a:solidFill>
               </a:rPr>
-              <a:t>Extension à Marshall (0,9 %) et autres fournisseurs.</a:t>
+              <a:t>Casques et écouteurs · 6,7 %</a:t>
+            </a:r>
+            <a:endParaRPr lang="en-US" sz="1600" dirty="0"/>
+          </a:p>
+          <a:p>
+            <a:pPr marL="342900" indent="-342900">
+              <a:spcAft>
+                <a:spcPts val="800"/>
+              </a:spcAft>
+              <a:buSzPct val="100000"/>
+              <a:buChar char="•"/>
+            </a:pPr>
+            <a:r>
+              <a:rPr lang="en-US" sz="1400" dirty="0">
+                <a:solidFill>
+                  <a:srgbClr val="1B2238"/>
+                </a:solidFill>
+              </a:rPr>
+              <a:t>Aspirateurs · 6,0 %</a:t>
             </a:r>
             <a:endParaRPr lang="en-US" sz="1600" dirty="0"/>
           </a:p>
@@ -5553,7 +5643,7 @@
                   <a:srgbClr val="1B2238"/>
                 </a:solidFill>
               </a:rPr>
-              <a:t>Roxane vous envoie le récapitulatif Bose et le format d'offre packagée (statut à confirmer avant envoi).</a:t>
+              <a:t>nous vous proposons une sélection resserrée sur ces quatre catégories, avec des références à bon rapport qualité-prix.</a:t>
             </a:r>
             <a:endParaRPr lang="en-US" sz="1400" dirty="0"/>
           </a:p>
@@ -5599,6 +5689,498 @@
             <a:fld id="{F7021451-1387-4CA6-816F-3879F97B5CBC}" type="slidenum">
               <a:rPr b="0" lang="en-US"/>
               <a:t>12</a:t>
+            </a:fld>
+            <a:endParaRPr lang="en-US"/>
+          </a:p>
+        </p:txBody>
+      </p:sp>
+    </p:spTree>
+  </p:cSld>
+  <p:clrMapOvr>
+    <a:masterClrMapping/>
+  </p:clrMapOvr>
+</p:sld>
+</file>
+
+<file path=ppt/slides/slide13.xml><?xml version="1.0" encoding="utf-8"?>
+<p:sld xmlns:a="http://schemas.openxmlformats.org/drawingml/2006/main" xmlns:r="http://schemas.openxmlformats.org/officeDocument/2006/relationships" xmlns:p="http://schemas.openxmlformats.org/presentationml/2006/main">
+  <p:cSld name="Slide 13">
+    <p:spTree>
+      <p:nvGrpSpPr>
+        <p:cNvPr id="1" name=""/>
+        <p:cNvGrpSpPr/>
+        <p:nvPr/>
+      </p:nvGrpSpPr>
+      <p:grpSpPr>
+        <a:xfrm>
+          <a:off x="0" y="0"/>
+          <a:ext cx="0" cy="0"/>
+          <a:chOff x="0" y="0"/>
+          <a:chExt cx="0" cy="0"/>
+        </a:xfrm>
+      </p:grpSpPr>
+      <p:sp>
+        <p:nvSpPr>
+          <p:cNvPr id="2" name="Text 0"/>
+          <p:cNvSpPr txBox="1"/>
+          <p:nvPr/>
+        </p:nvSpPr>
+        <p:spPr>
+          <a:xfrm>
+            <a:off x="548640" y="320040"/>
+            <a:ext cx="10972800" cy="320040"/>
+          </a:xfrm>
+          <a:prstGeom prst="rect">
+            <a:avLst/>
+          </a:prstGeom>
+          <a:noFill/>
+          <a:ln/>
+        </p:spPr>
+        <p:txBody>
+          <a:bodyPr wrap="square" lIns="0" tIns="0" rIns="0" bIns="0" rtlCol="0" anchor="ctr"/>
+          <a:lstStyle/>
+          <a:p>
+            <a:pPr indent="0" marL="0">
+              <a:buNone/>
+            </a:pPr>
+            <a:r>
+              <a:rPr lang="en-US" sz="1200" b="1" spc="200" kern="0" dirty="0">
+                <a:solidFill>
+                  <a:schemeClr val="accent1"/>
+                </a:solidFill>
+              </a:rPr>
+              <a:t>PISTE DE RECO</a:t>
+            </a:r>
+            <a:endParaRPr lang="en-US" sz="1200" dirty="0"/>
+          </a:p>
+        </p:txBody>
+      </p:sp>
+      <p:sp>
+        <p:nvSpPr>
+          <p:cNvPr id="3" name="Text 1"/>
+          <p:cNvSpPr txBox="1"/>
+          <p:nvPr/>
+        </p:nvSpPr>
+        <p:spPr>
+          <a:xfrm>
+            <a:off x="548640" y="640080"/>
+            <a:ext cx="11064240" cy="731520"/>
+          </a:xfrm>
+          <a:prstGeom prst="rect">
+            <a:avLst/>
+          </a:prstGeom>
+          <a:noFill/>
+          <a:ln/>
+        </p:spPr>
+        <p:txBody>
+          <a:bodyPr wrap="square" lIns="0" tIns="0" rIns="0" bIns="0" rtlCol="0" anchor="ctr"/>
+          <a:lstStyle/>
+          <a:p>
+            <a:pPr indent="0" marL="0">
+              <a:buNone/>
+            </a:pPr>
+            <a:r>
+              <a:rPr lang="en-US" sz="3000" b="1" dirty="0">
+                <a:solidFill>
+                  <a:schemeClr val="tx1"/>
+                </a:solidFill>
+              </a:rPr>
+              <a:t>Activer Bose, puis packager l'offre</a:t>
+            </a:r>
+            <a:endParaRPr lang="en-US" sz="3000" dirty="0"/>
+          </a:p>
+        </p:txBody>
+      </p:sp>
+      <p:sp>
+        <p:nvSpPr>
+          <p:cNvPr id="4" name="Text 2"/>
+          <p:cNvSpPr txBox="1"/>
+          <p:nvPr/>
+        </p:nvSpPr>
+        <p:spPr>
+          <a:xfrm>
+            <a:off x="548640" y="1371600"/>
+            <a:ext cx="11064240" cy="457200"/>
+          </a:xfrm>
+          <a:prstGeom prst="rect">
+            <a:avLst/>
+          </a:prstGeom>
+          <a:noFill/>
+          <a:ln/>
+        </p:spPr>
+        <p:txBody>
+          <a:bodyPr wrap="square" lIns="0" tIns="0" rIns="0" bIns="0" rtlCol="0" anchor="ctr"/>
+          <a:lstStyle/>
+          <a:p>
+            <a:pPr indent="0" marL="0">
+              <a:buNone/>
+            </a:pPr>
+            <a:r>
+              <a:rPr lang="en-US" sz="1400" dirty="0">
+                <a:solidFill>
+                  <a:srgbClr val="5A6275"/>
+                </a:solidFill>
+              </a:rPr>
+              <a:t>Bose pèse 2,2 % des conversations de la semaine : la demande existe dans vos catégories audio.</a:t>
+            </a:r>
+            <a:endParaRPr lang="en-US" sz="1400" dirty="0"/>
+          </a:p>
+        </p:txBody>
+      </p:sp>
+      <p:sp>
+        <p:nvSpPr>
+          <p:cNvPr id="5" name="Shape 3"/>
+          <p:cNvSpPr/>
+          <p:nvPr/>
+        </p:nvSpPr>
+        <p:spPr>
+          <a:xfrm>
+            <a:off x="548640" y="2011680"/>
+            <a:ext cx="5349240" cy="3429000"/>
+          </a:xfrm>
+          <a:prstGeom prst="roundRect">
+            <a:avLst>
+              <a:gd name="adj" fmla="val 2667"/>
+            </a:avLst>
+          </a:prstGeom>
+          <a:solidFill>
+            <a:srgbClr val="F2F4F8"/>
+          </a:solidFill>
+          <a:ln w="12700">
+            <a:solidFill>
+              <a:srgbClr val="F2F4F8"/>
+            </a:solidFill>
+            <a:prstDash val="solid"/>
+          </a:ln>
+        </p:spPr>
+      </p:sp>
+      <p:sp>
+        <p:nvSpPr>
+          <p:cNvPr id="6" name="Text 4"/>
+          <p:cNvSpPr txBox="1"/>
+          <p:nvPr/>
+        </p:nvSpPr>
+        <p:spPr>
+          <a:xfrm>
+            <a:off x="822960" y="2148840"/>
+            <a:ext cx="4800600" cy="3200400"/>
+          </a:xfrm>
+          <a:prstGeom prst="rect">
+            <a:avLst/>
+          </a:prstGeom>
+          <a:noFill/>
+          <a:ln/>
+        </p:spPr>
+        <p:txBody>
+          <a:bodyPr wrap="square" lIns="0" tIns="0" rIns="0" bIns="0" rtlCol="0" anchor="t"/>
+          <a:lstStyle/>
+          <a:p>
+            <a:pPr indent="0" marL="0">
+              <a:spcAft>
+                <a:spcPts val="800"/>
+              </a:spcAft>
+              <a:buNone/>
+            </a:pPr>
+            <a:r>
+              <a:rPr lang="en-US" sz="1600" b="1" dirty="0">
+                <a:solidFill>
+                  <a:srgbClr val="E8601C"/>
+                </a:solidFill>
+              </a:rPr>
+              <a:t>Le dispositif Bose</a:t>
+            </a:r>
+            <a:endParaRPr lang="en-US" sz="1600" dirty="0"/>
+          </a:p>
+          <a:p>
+            <a:pPr marL="342900" indent="-342900">
+              <a:spcAft>
+                <a:spcPts val="800"/>
+              </a:spcAft>
+              <a:buSzPct val="100000"/>
+              <a:buChar char="•"/>
+            </a:pPr>
+            <a:r>
+              <a:rPr lang="en-US" sz="1400" dirty="0">
+                <a:solidFill>
+                  <a:srgbClr val="1B2238"/>
+                </a:solidFill>
+              </a:rPr>
+              <a:t>Produits Bose dans les annonces IA, liens vers boulanger.com.</a:t>
+            </a:r>
+            <a:endParaRPr lang="en-US" sz="1600" dirty="0"/>
+          </a:p>
+          <a:p>
+            <a:pPr marL="342900" indent="-342900">
+              <a:spcAft>
+                <a:spcPts val="800"/>
+              </a:spcAft>
+              <a:buSzPct val="100000"/>
+              <a:buChar char="•"/>
+            </a:pPr>
+            <a:r>
+              <a:rPr lang="en-US" sz="1400" dirty="0">
+                <a:solidFill>
+                  <a:srgbClr val="1B2238"/>
+                </a:solidFill>
+              </a:rPr>
+              <a:t>Campagne distincte du fil rouge, avec ses propres indicateurs.</a:t>
+            </a:r>
+            <a:endParaRPr lang="en-US" sz="1600" dirty="0"/>
+          </a:p>
+          <a:p>
+            <a:pPr marL="342900" indent="-342900">
+              <a:spcAft>
+                <a:spcPts val="800"/>
+              </a:spcAft>
+              <a:buSzPct val="100000"/>
+              <a:buChar char="•"/>
+            </a:pPr>
+            <a:r>
+              <a:rPr lang="en-US" sz="1400" dirty="0">
+                <a:solidFill>
+                  <a:srgbClr val="1B2238"/>
+                </a:solidFill>
+              </a:rPr>
+              <a:t>Budget envisagé : 20 000 € / mois (à confirmer).</a:t>
+            </a:r>
+            <a:endParaRPr lang="en-US" sz="1600" dirty="0"/>
+          </a:p>
+        </p:txBody>
+      </p:sp>
+      <p:sp>
+        <p:nvSpPr>
+          <p:cNvPr id="7" name="Shape 5"/>
+          <p:cNvSpPr/>
+          <p:nvPr/>
+        </p:nvSpPr>
+        <p:spPr>
+          <a:xfrm>
+            <a:off x="6144768" y="2011680"/>
+            <a:ext cx="5349240" cy="3429000"/>
+          </a:xfrm>
+          <a:prstGeom prst="roundRect">
+            <a:avLst>
+              <a:gd name="adj" fmla="val 2667"/>
+            </a:avLst>
+          </a:prstGeom>
+          <a:solidFill>
+            <a:srgbClr val="F2F4F8"/>
+          </a:solidFill>
+          <a:ln w="12700">
+            <a:solidFill>
+              <a:srgbClr val="F2F4F8"/>
+            </a:solidFill>
+            <a:prstDash val="solid"/>
+          </a:ln>
+        </p:spPr>
+      </p:sp>
+      <p:sp>
+        <p:nvSpPr>
+          <p:cNvPr id="8" name="Text 6"/>
+          <p:cNvSpPr txBox="1"/>
+          <p:nvPr/>
+        </p:nvSpPr>
+        <p:spPr>
+          <a:xfrm>
+            <a:off x="6419088" y="2148840"/>
+            <a:ext cx="4800600" cy="3200400"/>
+          </a:xfrm>
+          <a:prstGeom prst="rect">
+            <a:avLst/>
+          </a:prstGeom>
+          <a:noFill/>
+          <a:ln/>
+        </p:spPr>
+        <p:txBody>
+          <a:bodyPr wrap="square" lIns="0" tIns="0" rIns="0" bIns="0" rtlCol="0" anchor="t"/>
+          <a:lstStyle/>
+          <a:p>
+            <a:pPr indent="0" marL="0">
+              <a:spcAft>
+                <a:spcPts val="800"/>
+              </a:spcAft>
+              <a:buNone/>
+            </a:pPr>
+            <a:r>
+              <a:rPr lang="en-US" sz="1600" b="1" dirty="0">
+                <a:solidFill>
+                  <a:srgbClr val="E8601C"/>
+                </a:solidFill>
+              </a:rPr>
+              <a:t>Le cadre à fixer ensemble</a:t>
+            </a:r>
+            <a:endParaRPr lang="en-US" sz="1600" dirty="0"/>
+          </a:p>
+          <a:p>
+            <a:pPr marL="342900" indent="-342900">
+              <a:spcAft>
+                <a:spcPts val="800"/>
+              </a:spcAft>
+              <a:buSzPct val="100000"/>
+              <a:buChar char="•"/>
+            </a:pPr>
+            <a:r>
+              <a:rPr lang="en-US" sz="1400" dirty="0">
+                <a:solidFill>
+                  <a:srgbClr val="1B2238"/>
+                </a:solidFill>
+              </a:rPr>
+              <a:t>Durée du test et critères de validation.</a:t>
+            </a:r>
+            <a:endParaRPr lang="en-US" sz="1600" dirty="0"/>
+          </a:p>
+          <a:p>
+            <a:pPr marL="342900" indent="-342900">
+              <a:spcAft>
+                <a:spcPts val="800"/>
+              </a:spcAft>
+              <a:buSzPct val="100000"/>
+              <a:buChar char="•"/>
+            </a:pPr>
+            <a:r>
+              <a:rPr lang="en-US" sz="1400" dirty="0">
+                <a:solidFill>
+                  <a:srgbClr val="1B2238"/>
+                </a:solidFill>
+              </a:rPr>
+              <a:t>Partage de revenu Boulanger / Lemrock.</a:t>
+            </a:r>
+            <a:endParaRPr lang="en-US" sz="1600" dirty="0"/>
+          </a:p>
+          <a:p>
+            <a:pPr marL="342900" indent="-342900">
+              <a:spcAft>
+                <a:spcPts val="800"/>
+              </a:spcAft>
+              <a:buSzPct val="100000"/>
+              <a:buChar char="•"/>
+            </a:pPr>
+            <a:r>
+              <a:rPr lang="en-US" sz="1400" dirty="0">
+                <a:solidFill>
+                  <a:srgbClr val="1B2238"/>
+                </a:solidFill>
+              </a:rPr>
+              <a:t>Extension à Marshall (0,9 %) et autres fournisseurs.</a:t>
+            </a:r>
+            <a:endParaRPr lang="en-US" sz="1600" dirty="0"/>
+          </a:p>
+        </p:txBody>
+      </p:sp>
+      <p:sp>
+        <p:nvSpPr>
+          <p:cNvPr id="9" name="Shape 7"/>
+          <p:cNvSpPr/>
+          <p:nvPr/>
+        </p:nvSpPr>
+        <p:spPr>
+          <a:xfrm>
+            <a:off x="548640" y="5623560"/>
+            <a:ext cx="11064240" cy="566928"/>
+          </a:xfrm>
+          <a:prstGeom prst="roundRect">
+            <a:avLst>
+              <a:gd name="adj" fmla="val 12903"/>
+            </a:avLst>
+          </a:prstGeom>
+          <a:solidFill>
+            <a:srgbClr val="F2F4F8"/>
+          </a:solidFill>
+          <a:ln w="12700">
+            <a:solidFill>
+              <a:srgbClr val="F2F4F8"/>
+            </a:solidFill>
+            <a:prstDash val="solid"/>
+          </a:ln>
+        </p:spPr>
+      </p:sp>
+      <p:sp>
+        <p:nvSpPr>
+          <p:cNvPr id="10" name="Text 8"/>
+          <p:cNvSpPr txBox="1"/>
+          <p:nvPr/>
+        </p:nvSpPr>
+        <p:spPr>
+          <a:xfrm>
+            <a:off x="731520" y="5623560"/>
+            <a:ext cx="10698480" cy="566928"/>
+          </a:xfrm>
+          <a:prstGeom prst="rect">
+            <a:avLst/>
+          </a:prstGeom>
+          <a:noFill/>
+          <a:ln/>
+        </p:spPr>
+        <p:txBody>
+          <a:bodyPr wrap="square" lIns="0" tIns="0" rIns="0" bIns="0" rtlCol="0" anchor="ctr"/>
+          <a:lstStyle/>
+          <a:p>
+            <a:pPr indent="0" marL="0">
+              <a:buNone/>
+            </a:pPr>
+            <a:r>
+              <a:rPr lang="en-US" sz="1400" b="1" dirty="0">
+                <a:solidFill>
+                  <a:srgbClr val="E8601C"/>
+                </a:solidFill>
+              </a:rPr>
+              <a:t>À retenir. </a:t>
+            </a:r>
+            <a:pPr indent="0" marL="0">
+              <a:buNone/>
+            </a:pPr>
+            <a:r>
+              <a:rPr lang="en-US" sz="1400" dirty="0">
+                <a:solidFill>
+                  <a:srgbClr val="1B2238"/>
+                </a:solidFill>
+              </a:rPr>
+              <a:t>Roxane vous envoie le récapitulatif Bose et le format d'offre packagée (statut à confirmer avant envoi).</a:t>
+            </a:r>
+            <a:endParaRPr lang="en-US" sz="1400" dirty="0"/>
+          </a:p>
+        </p:txBody>
+      </p:sp>
+      <p:sp>
+        <p:nvSpPr>
+          <p:cNvPr id="25" name="Slide Number Placeholder 0"/>
+          <p:cNvSpPr>
+            <a:spLocks noGrp="1"/>
+          </p:cNvSpPr>
+          <p:nvPr>
+            <p:ph type="sldNum" sz="quarter" idx="4294967295"/>
+          </p:nvPr>
+        </p:nvSpPr>
+        <p:spPr>
+          <a:xfrm>
+            <a:off x="11247120" y="6400800"/>
+            <a:ext cx="457200" cy="274320"/>
+          </a:xfrm>
+          <a:prstGeom prst="rect">
+            <a:avLst/>
+          </a:prstGeom>
+          <a:extLst>
+            <a:ext uri="{C572A759-6A51-4108-AA02-DFA0A04FC94B}">
+              <ma14:wrappingTextBoxFlag xmlns:ma14="http://schemas.microsoft.com/office/mac/drawingml/2011/main" val="0"/>
+            </a:ext>
+          </a:extLst>
+        </p:spPr>
+        <p:txBody>
+          <a:bodyPr/>
+          <a:lstStyle>
+            <a:lvl1pPr>
+              <a:defRPr sz="1000">
+                <a:solidFill>
+                  <a:srgbClr val="5A6275"/>
+                </a:solidFill>
+              </a:defRPr>
+            </a:lvl1pPr>
+          </a:lstStyle>
+          <a:p>
+            <a:pPr algn="l"/>
+            <a:fld id="{F7021451-1387-4CA6-816F-3879F97B5CBC}" type="slidenum">
+              <a:rPr b="0" lang="en-US"/>
+              <a:t>13</a:t>
             </a:fld>
             <a:endParaRPr lang="en-US"/>
           </a:p>
@@ -12797,7 +13379,7 @@
                   <a:schemeClr val="accent1"/>
                 </a:solidFill>
               </a:rPr>
-              <a:t>PISTE DE RECO</a:t>
+              <a:t>CHAMPS SÉMANTIQUES DES CONVERSATIONS</a:t>
             </a:r>
             <a:endParaRPr lang="en-US" sz="1200" dirty="0"/>
           </a:p>
@@ -12833,7 +13415,7 @@
                   <a:schemeClr val="tx1"/>
                 </a:solidFill>
               </a:rPr>
-              <a:t>Fiabiliser la mesure des conversions</a:t>
+              <a:t>Vacances, panne et smartphone dominent les conversations</a:t>
             </a:r>
             <a:endParaRPr lang="en-US" sz="3000" dirty="0"/>
           </a:p>
@@ -12848,7 +13430,7 @@
         <p:spPr>
           <a:xfrm>
             <a:off x="548640" y="1371600"/>
-            <a:ext cx="11064240" cy="457200"/>
+            <a:ext cx="10972800" cy="274320"/>
           </a:xfrm>
           <a:prstGeom prst="rect">
             <a:avLst/>
@@ -12864,31 +13446,431 @@
               <a:buNone/>
             </a:pPr>
             <a:r>
-              <a:rPr lang="en-US" sz="1400" dirty="0">
+              <a:rPr lang="en-US" sz="1100" dirty="0">
                 <a:solidFill>
                   <a:srgbClr val="5A6275"/>
                 </a:solidFill>
               </a:rPr>
-              <a:t>Les premières ventes remontent : 15 transactions et 2 103 € HT depuis le lancement, dont 6 cette semaine.</a:t>
-            </a:r>
-            <a:endParaRPr lang="en-US" sz="1400" dirty="0"/>
-          </a:p>
-        </p:txBody>
-      </p:sp>
-      <p:sp>
-        <p:nvSpPr>
-          <p:cNvPr id="5" name="Shape 3"/>
+              <a:t>PÉRIODE 01/10/2026 → 08/10/2026   ·   COMPARAISON vs 23/09 → 30/09</a:t>
+            </a:r>
+            <a:endParaRPr lang="en-US" sz="1100" dirty="0"/>
+          </a:p>
+        </p:txBody>
+      </p:sp>
+      <p:sp>
+        <p:nvSpPr>
+          <p:cNvPr id="5" name="Text 3"/>
+          <p:cNvSpPr txBox="1"/>
+          <p:nvPr/>
+        </p:nvSpPr>
+        <p:spPr>
+          <a:xfrm>
+            <a:off x="548640" y="1737360"/>
+            <a:ext cx="11064240" cy="3566160"/>
+          </a:xfrm>
+          <a:prstGeom prst="rect">
+            <a:avLst/>
+          </a:prstGeom>
+          <a:noFill/>
+          <a:ln/>
+        </p:spPr>
+        <p:txBody>
+          <a:bodyPr wrap="square" lIns="0" tIns="0" rIns="0" bIns="0" rtlCol="0" anchor="ctr"/>
+          <a:lstStyle/>
+          <a:p>
+            <a:pPr algn="ctr" indent="0" marL="0">
+              <a:lnSpc>
+                <a:spcPct val="105000"/>
+              </a:lnSpc>
+              <a:buNone/>
+            </a:pPr>
+            <a:r>
+              <a:rPr lang="en-US" sz="2500" b="1" dirty="0">
+                <a:solidFill>
+                  <a:srgbClr val="E8601C"/>
+                </a:solidFill>
+              </a:rPr>
+              <a:t>aspirateur     </a:t>
+            </a:r>
+            <a:pPr algn="ctr" indent="0" marL="0">
+              <a:lnSpc>
+                <a:spcPct val="105000"/>
+              </a:lnSpc>
+              <a:buNone/>
+            </a:pPr>
+            <a:r>
+              <a:rPr lang="en-US" sz="4000" b="1" dirty="0">
+                <a:solidFill>
+                  <a:srgbClr val="1B2238"/>
+                </a:solidFill>
+              </a:rPr>
+              <a:t>départ en vacances     </a:t>
+            </a:r>
+            <a:pPr algn="ctr" indent="0" marL="0">
+              <a:lnSpc>
+                <a:spcPct val="105000"/>
+              </a:lnSpc>
+              <a:buNone/>
+            </a:pPr>
+            <a:r>
+              <a:rPr lang="en-US" sz="4000" b="1" dirty="0">
+                <a:solidFill>
+                  <a:srgbClr val="E8601C"/>
+                </a:solidFill>
+              </a:rPr>
+              <a:t>smartphone</a:t>
+            </a:r>
+            <a:endParaRPr lang="en-US" sz="2500" dirty="0"/>
+          </a:p>
+          <a:p>
+            <a:pPr algn="ctr" indent="0" marL="0">
+              <a:lnSpc>
+                <a:spcPct val="105000"/>
+              </a:lnSpc>
+              <a:buNone/>
+            </a:pPr>
+            <a:r>
+              <a:rPr lang="en-US" sz="2600" b="1" dirty="0">
+                <a:solidFill>
+                  <a:srgbClr val="8A93A6"/>
+                </a:solidFill>
+              </a:rPr>
+              <a:t>compatibilité     </a:t>
+            </a:r>
+            <a:pPr algn="ctr" indent="0" marL="0">
+              <a:lnSpc>
+                <a:spcPct val="105000"/>
+              </a:lnSpc>
+              <a:buNone/>
+            </a:pPr>
+            <a:r>
+              <a:rPr lang="en-US" sz="4000" b="1" dirty="0">
+                <a:solidFill>
+                  <a:srgbClr val="8A93A6"/>
+                </a:solidFill>
+              </a:rPr>
+              <a:t>prix     </a:t>
+            </a:r>
+            <a:pPr algn="ctr" indent="0" marL="0">
+              <a:lnSpc>
+                <a:spcPct val="105000"/>
+              </a:lnSpc>
+              <a:buNone/>
+            </a:pPr>
+            <a:r>
+              <a:rPr lang="en-US" sz="2800" b="1" dirty="0">
+                <a:solidFill>
+                  <a:srgbClr val="E8601C"/>
+                </a:solidFill>
+              </a:rPr>
+              <a:t>enceinte     </a:t>
+            </a:r>
+            <a:pPr algn="ctr" indent="0" marL="0">
+              <a:lnSpc>
+                <a:spcPct val="105000"/>
+              </a:lnSpc>
+              <a:buNone/>
+            </a:pPr>
+            <a:r>
+              <a:rPr lang="en-US" sz="2400" b="1" dirty="0">
+                <a:solidFill>
+                  <a:srgbClr val="1B2238"/>
+                </a:solidFill>
+              </a:rPr>
+              <a:t>équipement enfant</a:t>
+            </a:r>
+            <a:endParaRPr lang="en-US" sz="2500" dirty="0"/>
+          </a:p>
+          <a:p>
+            <a:pPr algn="ctr" indent="0" marL="0">
+              <a:lnSpc>
+                <a:spcPct val="105000"/>
+              </a:lnSpc>
+              <a:buNone/>
+            </a:pPr>
+            <a:r>
+              <a:rPr lang="en-US" sz="2700" b="1" dirty="0">
+                <a:solidFill>
+                  <a:srgbClr val="8A93A6"/>
+                </a:solidFill>
+              </a:rPr>
+              <a:t>rendu sonore     </a:t>
+            </a:r>
+            <a:pPr algn="ctr" indent="0" marL="0">
+              <a:lnSpc>
+                <a:spcPct val="105000"/>
+              </a:lnSpc>
+              <a:buNone/>
+            </a:pPr>
+            <a:r>
+              <a:rPr lang="en-US" sz="2700" b="1" dirty="0">
+                <a:solidFill>
+                  <a:srgbClr val="E8601C"/>
+                </a:solidFill>
+              </a:rPr>
+              <a:t>casque &amp; écouteurs     </a:t>
+            </a:r>
+            <a:pPr algn="ctr" indent="0" marL="0">
+              <a:lnSpc>
+                <a:spcPct val="105000"/>
+              </a:lnSpc>
+              <a:buNone/>
+            </a:pPr>
+            <a:r>
+              <a:rPr lang="en-US" sz="3500" b="1" dirty="0">
+                <a:solidFill>
+                  <a:srgbClr val="1B2238"/>
+                </a:solidFill>
+              </a:rPr>
+              <a:t>panne     </a:t>
+            </a:r>
+            <a:pPr algn="ctr" indent="0" marL="0">
+              <a:lnSpc>
+                <a:spcPct val="105000"/>
+              </a:lnSpc>
+              <a:buNone/>
+            </a:pPr>
+            <a:r>
+              <a:rPr lang="en-US" sz="2400" b="1" dirty="0">
+                <a:solidFill>
+                  <a:srgbClr val="E8601C"/>
+                </a:solidFill>
+              </a:rPr>
+              <a:t>écran PC</a:t>
+            </a:r>
+            <a:endParaRPr lang="en-US" sz="2500" dirty="0"/>
+          </a:p>
+          <a:p>
+            <a:pPr algn="ctr" indent="0" marL="0">
+              <a:lnSpc>
+                <a:spcPct val="105000"/>
+              </a:lnSpc>
+              <a:buNone/>
+            </a:pPr>
+            <a:r>
+              <a:rPr lang="en-US" sz="2000" b="1" dirty="0">
+                <a:solidFill>
+                  <a:srgbClr val="E8601C"/>
+                </a:solidFill>
+              </a:rPr>
+              <a:t>tablette     </a:t>
+            </a:r>
+            <a:pPr algn="ctr" indent="0" marL="0">
+              <a:lnSpc>
+                <a:spcPct val="105000"/>
+              </a:lnSpc>
+              <a:buNone/>
+            </a:pPr>
+            <a:r>
+              <a:rPr lang="en-US" sz="1900" b="1" dirty="0">
+                <a:solidFill>
+                  <a:srgbClr val="E8601C"/>
+                </a:solidFill>
+              </a:rPr>
+              <a:t>téléviseur     </a:t>
+            </a:r>
+            <a:pPr algn="ctr" indent="0" marL="0">
+              <a:lnSpc>
+                <a:spcPct val="105000"/>
+              </a:lnSpc>
+              <a:buNone/>
+            </a:pPr>
+            <a:r>
+              <a:rPr lang="en-US" sz="1900" b="1" dirty="0">
+                <a:solidFill>
+                  <a:srgbClr val="1B2238"/>
+                </a:solidFill>
+              </a:rPr>
+              <a:t>cadeau     </a:t>
+            </a:r>
+            <a:pPr algn="ctr" indent="0" marL="0">
+              <a:lnSpc>
+                <a:spcPct val="105000"/>
+              </a:lnSpc>
+              <a:buNone/>
+            </a:pPr>
+            <a:r>
+              <a:rPr lang="en-US" sz="2300" b="1" dirty="0">
+                <a:solidFill>
+                  <a:srgbClr val="E8601C"/>
+                </a:solidFill>
+              </a:rPr>
+              <a:t>PC portable     </a:t>
+            </a:r>
+            <a:pPr algn="ctr" indent="0" marL="0">
+              <a:lnSpc>
+                <a:spcPct val="105000"/>
+              </a:lnSpc>
+              <a:buNone/>
+            </a:pPr>
+            <a:r>
+              <a:rPr lang="en-US" sz="2300" b="1" dirty="0">
+                <a:solidFill>
+                  <a:srgbClr val="8A93A6"/>
+                </a:solidFill>
+              </a:rPr>
+              <a:t>autonomie</a:t>
+            </a:r>
+            <a:endParaRPr lang="en-US" sz="2500" dirty="0"/>
+          </a:p>
+          <a:p>
+            <a:pPr algn="ctr" indent="0" marL="0">
+              <a:lnSpc>
+                <a:spcPct val="105000"/>
+              </a:lnSpc>
+              <a:buNone/>
+            </a:pPr>
+            <a:r>
+              <a:rPr lang="en-US" sz="1800" b="1" dirty="0">
+                <a:solidFill>
+                  <a:srgbClr val="8A93A6"/>
+                </a:solidFill>
+              </a:rPr>
+              <a:t>qualité photo     </a:t>
+            </a:r>
+            <a:pPr algn="ctr" indent="0" marL="0">
+              <a:lnSpc>
+                <a:spcPct val="105000"/>
+              </a:lnSpc>
+              <a:buNone/>
+            </a:pPr>
+            <a:r>
+              <a:rPr lang="en-US" sz="2200" b="1" dirty="0">
+                <a:solidFill>
+                  <a:srgbClr val="1B2238"/>
+                </a:solidFill>
+              </a:rPr>
+              <a:t>étudiant     </a:t>
+            </a:r>
+            <a:pPr algn="ctr" indent="0" marL="0">
+              <a:lnSpc>
+                <a:spcPct val="105000"/>
+              </a:lnSpc>
+              <a:buNone/>
+            </a:pPr>
+            <a:r>
+              <a:rPr lang="en-US" sz="1800" b="1" dirty="0">
+                <a:solidFill>
+                  <a:srgbClr val="E8601C"/>
+                </a:solidFill>
+              </a:rPr>
+              <a:t>lave-linge     </a:t>
+            </a:r>
+            <a:pPr algn="ctr" indent="0" marL="0">
+              <a:lnSpc>
+                <a:spcPct val="105000"/>
+              </a:lnSpc>
+              <a:buNone/>
+            </a:pPr>
+            <a:r>
+              <a:rPr lang="en-US" sz="1800" b="1" dirty="0">
+                <a:solidFill>
+                  <a:srgbClr val="1B2238"/>
+                </a:solidFill>
+              </a:rPr>
+              <a:t>séparation     </a:t>
+            </a:r>
+            <a:pPr algn="ctr" indent="0" marL="0">
+              <a:lnSpc>
+                <a:spcPct val="105000"/>
+              </a:lnSpc>
+              <a:buNone/>
+            </a:pPr>
+            <a:r>
+              <a:rPr lang="en-US" sz="1800" b="1" dirty="0">
+                <a:solidFill>
+                  <a:srgbClr val="8A93A6"/>
+                </a:solidFill>
+              </a:rPr>
+              <a:t>taille d'écran</a:t>
+            </a:r>
+            <a:endParaRPr lang="en-US" sz="2500" dirty="0"/>
+          </a:p>
+        </p:txBody>
+      </p:sp>
+      <p:sp>
+        <p:nvSpPr>
+          <p:cNvPr id="6" name="Text 4"/>
+          <p:cNvSpPr txBox="1"/>
+          <p:nvPr/>
+        </p:nvSpPr>
+        <p:spPr>
+          <a:xfrm>
+            <a:off x="548640" y="5303520"/>
+            <a:ext cx="11064240" cy="320040"/>
+          </a:xfrm>
+          <a:prstGeom prst="rect">
+            <a:avLst/>
+          </a:prstGeom>
+          <a:noFill/>
+          <a:ln/>
+        </p:spPr>
+        <p:txBody>
+          <a:bodyPr wrap="square" lIns="0" tIns="0" rIns="0" bIns="0" rtlCol="0" anchor="ctr"/>
+          <a:lstStyle/>
+          <a:p>
+            <a:pPr algn="ctr" indent="0" marL="0">
+              <a:buNone/>
+            </a:pPr>
+            <a:r>
+              <a:rPr lang="en-US" sz="1200" dirty="0">
+                <a:solidFill>
+                  <a:srgbClr val="5A6275"/>
+                </a:solidFill>
+              </a:rPr>
+              <a:t>Taille du mot = fréquence au sein de sa famille     </a:t>
+            </a:r>
+            <a:pPr algn="ctr" indent="0" marL="0">
+              <a:buNone/>
+            </a:pPr>
+            <a:r>
+              <a:rPr lang="en-US" sz="1200" b="1" dirty="0">
+                <a:solidFill>
+                  <a:srgbClr val="E8601C"/>
+                </a:solidFill>
+              </a:rPr>
+              <a:t>● Produits   </a:t>
+            </a:r>
+            <a:pPr algn="ctr" indent="0" marL="0">
+              <a:buNone/>
+            </a:pPr>
+            <a:r>
+              <a:rPr lang="en-US" sz="1200" b="1" dirty="0">
+                <a:solidFill>
+                  <a:srgbClr val="1B2238"/>
+                </a:solidFill>
+              </a:rPr>
+              <a:t>● Occasions   </a:t>
+            </a:r>
+            <a:pPr algn="ctr" indent="0" marL="0">
+              <a:buNone/>
+            </a:pPr>
+            <a:r>
+              <a:rPr lang="en-US" sz="1200" b="1" dirty="0">
+                <a:solidFill>
+                  <a:srgbClr val="8A93A6"/>
+                </a:solidFill>
+              </a:rPr>
+              <a:t>● Critères d'achat</a:t>
+            </a:r>
+            <a:endParaRPr lang="en-US" sz="1200" dirty="0"/>
+          </a:p>
+        </p:txBody>
+      </p:sp>
+      <p:sp>
+        <p:nvSpPr>
+          <p:cNvPr id="7" name="Shape 5"/>
           <p:cNvSpPr/>
           <p:nvPr/>
         </p:nvSpPr>
         <p:spPr>
           <a:xfrm>
-            <a:off x="548640" y="2011680"/>
-            <a:ext cx="5349240" cy="3429000"/>
+            <a:off x="548640" y="5715000"/>
+            <a:ext cx="11064240" cy="566928"/>
           </a:xfrm>
           <a:prstGeom prst="roundRect">
             <a:avLst>
-              <a:gd name="adj" fmla="val 2667"/>
+              <a:gd name="adj" fmla="val 12903"/>
             </a:avLst>
           </a:prstGeom>
           <a:solidFill>
@@ -12904,14 +13886,14 @@
       </p:sp>
       <p:sp>
         <p:nvSpPr>
-          <p:cNvPr id="6" name="Text 4"/>
+          <p:cNvPr id="8" name="Text 6"/>
           <p:cNvSpPr txBox="1"/>
           <p:nvPr/>
         </p:nvSpPr>
         <p:spPr>
           <a:xfrm>
-            <a:off x="822960" y="2148840"/>
-            <a:ext cx="4800600" cy="3200400"/>
+            <a:off x="731520" y="5715000"/>
+            <a:ext cx="10698480" cy="566928"/>
           </a:xfrm>
           <a:prstGeom prst="rect">
             <a:avLst/>
@@ -12920,32 +13902,22 @@
           <a:ln/>
         </p:spPr>
         <p:txBody>
-          <a:bodyPr wrap="square" lIns="0" tIns="0" rIns="0" bIns="0" rtlCol="0" anchor="t"/>
+          <a:bodyPr wrap="square" lIns="0" tIns="0" rIns="0" bIns="0" rtlCol="0" anchor="ctr"/>
           <a:lstStyle/>
           <a:p>
             <a:pPr indent="0" marL="0">
-              <a:spcAft>
-                <a:spcPts val="800"/>
-              </a:spcAft>
-              <a:buNone/>
-            </a:pPr>
-            <a:r>
-              <a:rPr lang="en-US" sz="1600" b="1" dirty="0">
+              <a:buNone/>
+            </a:pPr>
+            <a:r>
+              <a:rPr lang="en-US" sz="1400" b="1" dirty="0">
                 <a:solidFill>
                   <a:srgbClr val="E8601C"/>
                 </a:solidFill>
               </a:rPr>
-              <a:t>Ce que disent les chiffres</a:t>
-            </a:r>
-            <a:endParaRPr lang="en-US" sz="1600" dirty="0"/>
-          </a:p>
-          <a:p>
-            <a:pPr marL="342900" indent="-342900">
-              <a:spcAft>
-                <a:spcPts val="800"/>
-              </a:spcAft>
-              <a:buSzPct val="100000"/>
-              <a:buChar char="•"/>
+              <a:t>À retenir. </a:t>
+            </a:r>
+            <a:pPr indent="0" marL="0">
+              <a:buNone/>
             </a:pPr>
             <a:r>
               <a:rPr lang="en-US" sz="1400" dirty="0">
@@ -12953,237 +13925,7 @@
                   <a:srgbClr val="1B2238"/>
                 </a:solidFill>
               </a:rPr>
-              <a:t>1–8 oct. : 6 transactions, 888,68 € HT, panier moyen 148 €.</a:t>
-            </a:r>
-            <a:endParaRPr lang="en-US" sz="1600" dirty="0"/>
-          </a:p>
-          <a:p>
-            <a:pPr marL="342900" indent="-342900">
-              <a:spcAft>
-                <a:spcPts val="800"/>
-              </a:spcAft>
-              <a:buSzPct val="100000"/>
-              <a:buChar char="•"/>
-            </a:pPr>
-            <a:r>
-              <a:rPr lang="en-US" sz="1400" dirty="0">
-                <a:solidFill>
-                  <a:srgbClr val="1B2238"/>
-                </a:solidFill>
-              </a:rPr>
-              <a:t>6 sur 6 réalisées par de nouveaux clients.</a:t>
-            </a:r>
-            <a:endParaRPr lang="en-US" sz="1600" dirty="0"/>
-          </a:p>
-          <a:p>
-            <a:pPr marL="342900" indent="-342900">
-              <a:spcAft>
-                <a:spcPts val="800"/>
-              </a:spcAft>
-              <a:buSzPct val="100000"/>
-              <a:buChar char="•"/>
-            </a:pPr>
-            <a:r>
-              <a:rPr lang="en-US" sz="1400" dirty="0">
-                <a:solidFill>
-                  <a:srgbClr val="1B2238"/>
-                </a:solidFill>
-              </a:rPr>
-              <a:t>CVR 0,29 % sur 2 039 visites (0,12 % la semaine précédente).</a:t>
-            </a:r>
-            <a:endParaRPr lang="en-US" sz="1600" dirty="0"/>
-          </a:p>
-        </p:txBody>
-      </p:sp>
-      <p:sp>
-        <p:nvSpPr>
-          <p:cNvPr id="7" name="Shape 5"/>
-          <p:cNvSpPr/>
-          <p:nvPr/>
-        </p:nvSpPr>
-        <p:spPr>
-          <a:xfrm>
-            <a:off x="6144768" y="2011680"/>
-            <a:ext cx="5349240" cy="3429000"/>
-          </a:xfrm>
-          <a:prstGeom prst="roundRect">
-            <a:avLst>
-              <a:gd name="adj" fmla="val 2667"/>
-            </a:avLst>
-          </a:prstGeom>
-          <a:solidFill>
-            <a:srgbClr val="F2F4F8"/>
-          </a:solidFill>
-          <a:ln w="12700">
-            <a:solidFill>
-              <a:srgbClr val="F2F4F8"/>
-            </a:solidFill>
-            <a:prstDash val="solid"/>
-          </a:ln>
-        </p:spPr>
-      </p:sp>
-      <p:sp>
-        <p:nvSpPr>
-          <p:cNvPr id="8" name="Text 6"/>
-          <p:cNvSpPr txBox="1"/>
-          <p:nvPr/>
-        </p:nvSpPr>
-        <p:spPr>
-          <a:xfrm>
-            <a:off x="6419088" y="2148840"/>
-            <a:ext cx="4800600" cy="3200400"/>
-          </a:xfrm>
-          <a:prstGeom prst="rect">
-            <a:avLst/>
-          </a:prstGeom>
-          <a:noFill/>
-          <a:ln/>
-        </p:spPr>
-        <p:txBody>
-          <a:bodyPr wrap="square" lIns="0" tIns="0" rIns="0" bIns="0" rtlCol="0" anchor="t"/>
-          <a:lstStyle/>
-          <a:p>
-            <a:pPr indent="0" marL="0">
-              <a:spcAft>
-                <a:spcPts val="800"/>
-              </a:spcAft>
-              <a:buNone/>
-            </a:pPr>
-            <a:r>
-              <a:rPr lang="en-US" sz="1600" b="1" dirty="0">
-                <a:solidFill>
-                  <a:srgbClr val="E8601C"/>
-                </a:solidFill>
-              </a:rPr>
-              <a:t>Les points à lever</a:t>
-            </a:r>
-            <a:endParaRPr lang="en-US" sz="1600" dirty="0"/>
-          </a:p>
-          <a:p>
-            <a:pPr marL="342900" indent="-342900">
-              <a:spcAft>
-                <a:spcPts val="800"/>
-              </a:spcAft>
-              <a:buSzPct val="100000"/>
-              <a:buChar char="•"/>
-            </a:pPr>
-            <a:r>
-              <a:rPr lang="en-US" sz="1400" dirty="0">
-                <a:solidFill>
-                  <a:srgbClr val="1B2238"/>
-                </a:solidFill>
-              </a:rPr>
-              <a:t>Écart clics / visites : 6 468 clics Lemrock pour 2 039 visites mesurées (31 %).</a:t>
-            </a:r>
-            <a:endParaRPr lang="en-US" sz="1600" dirty="0"/>
-          </a:p>
-          <a:p>
-            <a:pPr marL="342900" indent="-342900">
-              <a:spcAft>
-                <a:spcPts val="800"/>
-              </a:spcAft>
-              <a:buSzPct val="100000"/>
-              <a:buChar char="•"/>
-            </a:pPr>
-            <a:r>
-              <a:rPr lang="en-US" sz="1400" dirty="0">
-                <a:solidFill>
-                  <a:srgbClr val="1B2238"/>
-                </a:solidFill>
-              </a:rPr>
-              <a:t>Paramètre at_medium et consentement Didomi : à finaliser pour réduire cet écart.</a:t>
-            </a:r>
-            <a:endParaRPr lang="en-US" sz="1600" dirty="0"/>
-          </a:p>
-          <a:p>
-            <a:pPr marL="342900" indent="-342900">
-              <a:spcAft>
-                <a:spcPts val="800"/>
-              </a:spcAft>
-              <a:buSzPct val="100000"/>
-              <a:buChar char="•"/>
-            </a:pPr>
-            <a:r>
-              <a:rPr lang="en-US" sz="1400" dirty="0">
-                <a:solidFill>
-                  <a:srgbClr val="1B2238"/>
-                </a:solidFill>
-              </a:rPr>
-              <a:t>ROAS de la semaine : 0,38 (CA HT / budget).</a:t>
-            </a:r>
-            <a:endParaRPr lang="en-US" sz="1600" dirty="0"/>
-          </a:p>
-        </p:txBody>
-      </p:sp>
-      <p:sp>
-        <p:nvSpPr>
-          <p:cNvPr id="9" name="Shape 7"/>
-          <p:cNvSpPr/>
-          <p:nvPr/>
-        </p:nvSpPr>
-        <p:spPr>
-          <a:xfrm>
-            <a:off x="548640" y="5623560"/>
-            <a:ext cx="11064240" cy="566928"/>
-          </a:xfrm>
-          <a:prstGeom prst="roundRect">
-            <a:avLst>
-              <a:gd name="adj" fmla="val 12903"/>
-            </a:avLst>
-          </a:prstGeom>
-          <a:solidFill>
-            <a:srgbClr val="F2F4F8"/>
-          </a:solidFill>
-          <a:ln w="12700">
-            <a:solidFill>
-              <a:srgbClr val="F2F4F8"/>
-            </a:solidFill>
-            <a:prstDash val="solid"/>
-          </a:ln>
-        </p:spPr>
-      </p:sp>
-      <p:sp>
-        <p:nvSpPr>
-          <p:cNvPr id="10" name="Text 8"/>
-          <p:cNvSpPr txBox="1"/>
-          <p:nvPr/>
-        </p:nvSpPr>
-        <p:spPr>
-          <a:xfrm>
-            <a:off x="731520" y="5623560"/>
-            <a:ext cx="10698480" cy="566928"/>
-          </a:xfrm>
-          <a:prstGeom prst="rect">
-            <a:avLst/>
-          </a:prstGeom>
-          <a:noFill/>
-          <a:ln/>
-        </p:spPr>
-        <p:txBody>
-          <a:bodyPr wrap="square" lIns="0" tIns="0" rIns="0" bIns="0" rtlCol="0" anchor="ctr"/>
-          <a:lstStyle/>
-          <a:p>
-            <a:pPr indent="0" marL="0">
-              <a:buNone/>
-            </a:pPr>
-            <a:r>
-              <a:rPr lang="en-US" sz="1400" b="1" dirty="0">
-                <a:solidFill>
-                  <a:srgbClr val="E8601C"/>
-                </a:solidFill>
-              </a:rPr>
-              <a:t>À retenir. </a:t>
-            </a:r>
-            <a:pPr indent="0" marL="0">
-              <a:buNone/>
-            </a:pPr>
-            <a:r>
-              <a:rPr lang="en-US" sz="1400" dirty="0">
-                <a:solidFill>
-                  <a:srgbClr val="1B2238"/>
-                </a:solidFill>
-              </a:rPr>
-              <a:t>réconcilier clics et visites avec vos équipes pour que chaque vente attribuée à Lemrock soit comptée.</a:t>
+              <a:t>le prix est le premier critère d'achat ; le smartphone, la première demande produit ; vacances et panne, les premiers déclencheurs.</a:t>
             </a:r>
             <a:endParaRPr lang="en-US" sz="1400" dirty="0"/>
           </a:p>

</xml_diff>

<commit_message>
Rapport Boulanger 01.10-08.10 : moments de vie remplacés par marques et produits
Co-Authored-By: Claude Opus 5.5 <noreply@anthropic.com>
Claude-Session: https://claude.ai/code/session_018e7SCuQygFSJNrAfjS85j9
</commit_message>
<xml_diff>
--- a/rapports/In progress_20261009_Rapport_Boulanger_Hebdo_01.10-08.10.pptx
+++ b/rapports/In progress_20261009_Rapport_Boulanger_Hebdo_01.10-08.10.pptx
@@ -119,12 +119,12 @@
   <p:extLst>
     <p:ext uri="{521415D9-36F7-43E2-AB2F-B90AF26B5E84}">
       <p14:sectionLst xmlns:p14="http://schemas.microsoft.com/office/powerpoint/2010/main">
-        <p14:section name="Introduction" id="{673ec8b9-c386-070f-0962-b594f2b5ff58}">
+        <p14:section name="Introduction" id="{bed7f8c1-03a9-a7de-87ae-57f2130ea07e}">
           <p14:sldIdLst>
             <p14:sldId id="256"/>
           </p14:sldIdLst>
         </p14:section>
-        <p14:section name="Boulanger" id="{38c507cc-3f94-4d71-3d51-56572417def4}">
+        <p14:section name="Boulanger" id="{dc50a66d-085d-4533-5f20-e1c4305fb83c}">
           <p14:sldIdLst>
             <p14:sldId id="257"/>
             <p14:sldId id="258"/>
@@ -136,7 +136,7 @@
             <p14:sldId id="264"/>
           </p14:sldIdLst>
         </p14:section>
-        <p14:section name="Pistes de reco" id="{7d49d753-d0c6-771f-a765-36cb67ffde03}">
+        <p14:section name="Pistes de reco" id="{35ce37f4-147e-36dc-afa0-201f6414a7ed}">
           <p14:sldIdLst>
             <p14:sldId id="265"/>
             <p14:sldId id="266"/>
@@ -1569,7 +1569,7 @@
                 </a:solidFill>
                 <a:latin typeface="+mn-lt"/>
               </a:rPr>
-              <a:t>Moments de vie · part des conversations · 1–8 oct.</a:t>
+              <a:t>Top 10 marques · part des conversations · 1–8 oct.</a:t>
             </a:r>
           </a:p>
         </c:rich>
@@ -1600,7 +1600,7 @@
           </c:tx>
           <c:spPr>
             <a:solidFill>
-              <a:srgbClr val="E8601C"/>
+              <a:srgbClr val="1B2238"/>
             </a:solidFill>
             <a:effectLst/>
           </c:spPr>
@@ -1631,30 +1631,39 @@
           </c:dLbls>
           <c:cat>
             <c:multiLvlStrRef>
-              <c:f>Sheet1!$A$2:$A$8</c:f>
+              <c:f>Sheet1!$A$2:$A$11</c:f>
               <c:multiLvlStrCache>
-                <c:ptCount val="7"/>
+                <c:ptCount val="10"/>
                 <c:lvl>
                   <c:pt idx="0">
-                    <c:v>Départ en vacances</c:v>
+                    <c:v>Apple</c:v>
                   </c:pt>
                   <c:pt idx="1">
-                    <c:v>Remplacement après panne</c:v>
+                    <c:v>Samsung</c:v>
                   </c:pt>
                   <c:pt idx="2">
-                    <c:v>Équipement d'un enfant</c:v>
+                    <c:v>Xiaomi</c:v>
                   </c:pt>
                   <c:pt idx="3">
-                    <c:v>Équipement d'un étudiant</c:v>
+                    <c:v>Google</c:v>
                   </c:pt>
                   <c:pt idx="4">
-                    <c:v>Cadeau</c:v>
+                    <c:v>Sony</c:v>
                   </c:pt>
                   <c:pt idx="5">
-                    <c:v>Séparation</c:v>
+                    <c:v>JBL</c:v>
                   </c:pt>
                   <c:pt idx="6">
-                    <c:v>Équip. personne âgée</c:v>
+                    <c:v>Dreame</c:v>
+                  </c:pt>
+                  <c:pt idx="7">
+                    <c:v>Honor</c:v>
+                  </c:pt>
+                  <c:pt idx="8">
+                    <c:v>Roborock</c:v>
+                  </c:pt>
+                  <c:pt idx="9">
+                    <c:v>LG</c:v>
                   </c:pt>
                 </c:lvl>
               </c:multiLvlStrCache>
@@ -1662,30 +1671,39 @@
           </c:cat>
           <c:val>
             <c:numRef>
-              <c:f>Sheet1!$B$2:$B$8</c:f>
+              <c:f>Sheet1!$B$2:$B$11</c:f>
               <c:numCache>
                 <c:formatCode>General</c:formatCode>
-                <c:ptCount val="7"/>
+                <c:ptCount val="10"/>
                 <c:pt idx="0">
-                  <c:v>23</c:v>
+                  <c:v>9.3</c:v>
                 </c:pt>
                 <c:pt idx="1">
-                  <c:v>19.5</c:v>
+                  <c:v>8.4</c:v>
                 </c:pt>
                 <c:pt idx="2">
-                  <c:v>12.9</c:v>
+                  <c:v>5.5</c:v>
                 </c:pt>
                 <c:pt idx="3">
-                  <c:v>11.2</c:v>
+                  <c:v>5.1</c:v>
                 </c:pt>
                 <c:pt idx="4">
-                  <c:v>9.8</c:v>
+                  <c:v>4</c:v>
                 </c:pt>
                 <c:pt idx="5">
-                  <c:v>8.9</c:v>
+                  <c:v>3.1</c:v>
                 </c:pt>
                 <c:pt idx="6">
-                  <c:v>4.8</c:v>
+                  <c:v>3</c:v>
+                </c:pt>
+                <c:pt idx="7">
+                  <c:v>2.7</c:v>
+                </c:pt>
+                <c:pt idx="8">
+                  <c:v>2.7</c:v>
+                </c:pt>
+                <c:pt idx="9">
+                  <c:v>2.7</c:v>
                 </c:pt>
               </c:numCache>
             </c:numRef>
@@ -12943,7 +12961,7 @@
                   <a:schemeClr val="accent1"/>
                 </a:solidFill>
               </a:rPr>
-              <a:t>CE QUI DÉCLENCHE LES CONVERSATIONS</a:t>
+              <a:t>MARQUES ET MODÈLES NOMMÉS</a:t>
             </a:r>
             <a:endParaRPr lang="en-US" sz="1200" dirty="0"/>
           </a:p>
@@ -12979,7 +12997,7 @@
                   <a:schemeClr val="tx1"/>
                 </a:solidFill>
               </a:rPr>
-              <a:t>Le remplacement après panne monte à 19,5 % des moments de vie</a:t>
+              <a:t>Apple et Samsung, les deux marques les plus nommées</a:t>
             </a:r>
             <a:endParaRPr lang="en-US" sz="3000" dirty="0"/>
           </a:p>
@@ -13029,7 +13047,7 @@
         </p:nvGraphicFramePr>
         <p:xfrm>
           <a:off x="548640" y="1691640"/>
-          <a:ext cx="6583680" cy="3840480"/>
+          <a:ext cx="5852160" cy="3840480"/>
         </p:xfrm>
         <a:graphic xmlns:a="http://schemas.openxmlformats.org/drawingml/2006/main">
           <a:graphicData uri="http://schemas.openxmlformats.org/drawingml/2006/chart">
@@ -13045,8 +13063,8 @@
         </p:nvSpPr>
         <p:spPr>
           <a:xfrm>
-            <a:off x="7498080" y="1783080"/>
-            <a:ext cx="4114800" cy="3657600"/>
+            <a:off x="6675120" y="1783080"/>
+            <a:ext cx="4937760" cy="3657600"/>
           </a:xfrm>
           <a:prstGeom prst="roundRect">
             <a:avLst>
@@ -13072,8 +13090,8 @@
         </p:nvSpPr>
         <p:spPr>
           <a:xfrm>
-            <a:off x="7726680" y="1920240"/>
-            <a:ext cx="3657600" cy="3383280"/>
+            <a:off x="6903720" y="1920240"/>
+            <a:ext cx="4480560" cy="3383280"/>
           </a:xfrm>
           <a:prstGeom prst="rect">
             <a:avLst/>
@@ -13097,7 +13115,7 @@
                   <a:srgbClr val="1B2238"/>
                 </a:solidFill>
               </a:rPr>
-              <a:t>Usages recherchés</a:t>
+              <a:t>Modèles les plus cités</a:t>
             </a:r>
             <a:endParaRPr lang="en-US" sz="1600" dirty="0"/>
           </a:p>
@@ -13109,16 +13127,13 @@
               <a:buNone/>
             </a:pPr>
             <a:r>
-              <a:rPr lang="en-US" sz="1400" dirty="0">
-                <a:solidFill>
-                  <a:srgbClr val="1B2238"/>
-                </a:solidFill>
-              </a:rPr>
-              <a:t>Écoute musicale · 7,4 %</a:t>
-            </a:r>
-            <a:endParaRPr lang="en-US" sz="1600" dirty="0"/>
-          </a:p>
-          <a:p>
+              <a:rPr lang="en-US" sz="1300" b="1" dirty="0">
+                <a:solidFill>
+                  <a:srgbClr val="E8601C"/>
+                </a:solidFill>
+              </a:rPr>
+              <a:t>Apple : </a:t>
+            </a:r>
             <a:pPr indent="0" marL="0">
               <a:spcAft>
                 <a:spcPts val="600"/>
@@ -13126,12 +13141,12 @@
               <a:buNone/>
             </a:pPr>
             <a:r>
-              <a:rPr lang="en-US" sz="1400" dirty="0">
+              <a:rPr lang="en-US" sz="1300" dirty="0">
                 <a:solidFill>
                   <a:srgbClr val="1B2238"/>
                 </a:solidFill>
               </a:rPr>
-              <a:t>Jeu vidéo · 6,6 %</a:t>
+              <a:t>iPhone 17 Pro, iPhone 18 Pro · AirPods Pro 3</a:t>
             </a:r>
             <a:endParaRPr lang="en-US" sz="1600" dirty="0"/>
           </a:p>
@@ -13143,16 +13158,13 @@
               <a:buNone/>
             </a:pPr>
             <a:r>
-              <a:rPr lang="en-US" sz="1400" dirty="0">
-                <a:solidFill>
-                  <a:srgbClr val="1B2238"/>
-                </a:solidFill>
-              </a:rPr>
-              <a:t>Bureautique · 5,2 %</a:t>
-            </a:r>
-            <a:endParaRPr lang="en-US" sz="1600" dirty="0"/>
-          </a:p>
-          <a:p>
+              <a:rPr lang="en-US" sz="1300" b="1" dirty="0">
+                <a:solidFill>
+                  <a:srgbClr val="E8601C"/>
+                </a:solidFill>
+              </a:rPr>
+              <a:t>Samsung : </a:t>
+            </a:r>
             <a:pPr indent="0" marL="0">
               <a:spcAft>
                 <a:spcPts val="600"/>
@@ -13160,12 +13172,12 @@
               <a:buNone/>
             </a:pPr>
             <a:r>
-              <a:rPr lang="en-US" sz="1400" dirty="0">
+              <a:rPr lang="en-US" sz="1300" dirty="0">
                 <a:solidFill>
                   <a:srgbClr val="1B2238"/>
                 </a:solidFill>
               </a:rPr>
-              <a:t>Maison avec animaux · 5,1 %</a:t>
+              <a:t>Galaxy S25, S26 · Galaxy Tab A11+</a:t>
             </a:r>
             <a:endParaRPr lang="en-US" sz="1600" dirty="0"/>
           </a:p>
@@ -13177,16 +13189,13 @@
               <a:buNone/>
             </a:pPr>
             <a:r>
-              <a:rPr lang="en-US" sz="1400" dirty="0">
-                <a:solidFill>
-                  <a:srgbClr val="1B2238"/>
-                </a:solidFill>
-              </a:rPr>
-              <a:t>Films et séries · 4,5 %</a:t>
-            </a:r>
-            <a:endParaRPr lang="en-US" sz="1600" dirty="0"/>
-          </a:p>
-          <a:p>
+              <a:rPr lang="en-US" sz="1300" b="1" dirty="0">
+                <a:solidFill>
+                  <a:srgbClr val="E8601C"/>
+                </a:solidFill>
+              </a:rPr>
+              <a:t>Xiaomi : </a:t>
+            </a:r>
             <a:pPr indent="0" marL="0">
               <a:spcAft>
                 <a:spcPts val="600"/>
@@ -13194,12 +13203,105 @@
               <a:buNone/>
             </a:pPr>
             <a:r>
-              <a:rPr lang="en-US" sz="1300" i="1" dirty="0">
+              <a:rPr lang="en-US" sz="1300" dirty="0">
+                <a:solidFill>
+                  <a:srgbClr val="1B2238"/>
+                </a:solidFill>
+              </a:rPr>
+              <a:t>Redmi Note 15 Pro</a:t>
+            </a:r>
+            <a:endParaRPr lang="en-US" sz="1600" dirty="0"/>
+          </a:p>
+          <a:p>
+            <a:pPr indent="0" marL="0">
+              <a:spcAft>
+                <a:spcPts val="600"/>
+              </a:spcAft>
+              <a:buNone/>
+            </a:pPr>
+            <a:r>
+              <a:rPr lang="en-US" sz="1300" b="1" dirty="0">
                 <a:solidFill>
                   <a:srgbClr val="E8601C"/>
                 </a:solidFill>
               </a:rPr>
-              <a:t>Le Cadeau (9,8 %) apparaît dans le top 5 : premier signal avant la période des fêtes.</a:t>
+              <a:t>Google : </a:t>
+            </a:r>
+            <a:pPr indent="0" marL="0">
+              <a:spcAft>
+                <a:spcPts val="600"/>
+              </a:spcAft>
+              <a:buNone/>
+            </a:pPr>
+            <a:r>
+              <a:rPr lang="en-US" sz="1300" dirty="0">
+                <a:solidFill>
+                  <a:srgbClr val="1B2238"/>
+                </a:solidFill>
+              </a:rPr>
+              <a:t>Pixel 10a, Pixel 9a</a:t>
+            </a:r>
+            <a:endParaRPr lang="en-US" sz="1600" dirty="0"/>
+          </a:p>
+          <a:p>
+            <a:pPr indent="0" marL="0">
+              <a:spcAft>
+                <a:spcPts val="600"/>
+              </a:spcAft>
+              <a:buNone/>
+            </a:pPr>
+            <a:r>
+              <a:rPr lang="en-US" sz="1300" b="1" dirty="0">
+                <a:solidFill>
+                  <a:srgbClr val="E8601C"/>
+                </a:solidFill>
+              </a:rPr>
+              <a:t>Sony : </a:t>
+            </a:r>
+            <a:pPr indent="0" marL="0">
+              <a:spcAft>
+                <a:spcPts val="600"/>
+              </a:spcAft>
+              <a:buNone/>
+            </a:pPr>
+            <a:r>
+              <a:rPr lang="en-US" sz="1300" dirty="0">
+                <a:solidFill>
+                  <a:srgbClr val="1B2238"/>
+                </a:solidFill>
+              </a:rPr>
+              <a:t>WH-1000XM6 · BRAVIA 9 II</a:t>
+            </a:r>
+            <a:endParaRPr lang="en-US" sz="1600" dirty="0"/>
+          </a:p>
+          <a:p>
+            <a:pPr indent="0" marL="0">
+              <a:spcAft>
+                <a:spcPts val="600"/>
+              </a:spcAft>
+              <a:buNone/>
+            </a:pPr>
+            <a:r>
+              <a:rPr lang="en-US" sz="1300" b="1" dirty="0">
+                <a:solidFill>
+                  <a:srgbClr val="E8601C"/>
+                </a:solidFill>
+              </a:rPr>
+              <a:t>Dreame / Roborock : </a:t>
+            </a:r>
+            <a:pPr indent="0" marL="0">
+              <a:spcAft>
+                <a:spcPts val="600"/>
+              </a:spcAft>
+              <a:buNone/>
+            </a:pPr>
+            <a:r>
+              <a:rPr lang="en-US" sz="1300" dirty="0">
+                <a:solidFill>
+                  <a:srgbClr val="1B2238"/>
+                </a:solidFill>
+              </a:rPr>
+              <a:t>L40s Pro Ultra · Saros 20</a:t>
             </a:r>
             <a:endParaRPr lang="en-US" sz="1600" dirty="0"/>
           </a:p>
@@ -13273,7 +13375,7 @@
                   <a:srgbClr val="1B2238"/>
                 </a:solidFill>
               </a:rPr>
-              <a:t>panne (19,5 %) et cadeau (9,8 %) sont des moments d'achat à court terme, propices aux annonces produit.</a:t>
+              <a:t>30,7 % des recherches nomment déjà une marque ; le smartphone concentre les modèles les plus cités (iPhone, Galaxy, Redmi, Pixel).</a:t>
             </a:r>
             <a:endParaRPr lang="en-US" sz="1400" dirty="0"/>
           </a:p>
@@ -13415,7 +13517,7 @@
                   <a:schemeClr val="tx1"/>
                 </a:solidFill>
               </a:rPr>
-              <a:t>Vacances, panne et smartphone dominent les conversations</a:t>
+              <a:t>Smartphone, prix et Apple dominent les conversations</a:t>
             </a:r>
             <a:endParaRPr lang="en-US" sz="3000" dirty="0"/>
           </a:p>
@@ -13504,7 +13606,7 @@
                   <a:srgbClr val="1B2238"/>
                 </a:solidFill>
               </a:rPr>
-              <a:t>départ en vacances     </a:t>
+              <a:t>Apple     </a:t>
             </a:r>
             <a:pPr algn="ctr" indent="0" marL="0">
               <a:lnSpc>
@@ -13518,11 +13620,8 @@
                   <a:srgbClr val="E8601C"/>
                 </a:solidFill>
               </a:rPr>
-              <a:t>smartphone</a:t>
-            </a:r>
-            <a:endParaRPr lang="en-US" sz="2500" dirty="0"/>
-          </a:p>
-          <a:p>
+              <a:t>smartphone     </a:t>
+            </a:r>
             <a:pPr algn="ctr" indent="0" marL="0">
               <a:lnSpc>
                 <a:spcPct val="105000"/>
@@ -13535,8 +13634,11 @@
                   <a:srgbClr val="8A93A6"/>
                 </a:solidFill>
               </a:rPr>
-              <a:t>compatibilité     </a:t>
-            </a:r>
+              <a:t>compatibilité</a:t>
+            </a:r>
+            <a:endParaRPr lang="en-US" sz="2500" dirty="0"/>
+          </a:p>
+          <a:p>
             <a:pPr algn="ctr" indent="0" marL="0">
               <a:lnSpc>
                 <a:spcPct val="105000"/>
@@ -13544,12 +13646,12 @@
               <a:buNone/>
             </a:pPr>
             <a:r>
-              <a:rPr lang="en-US" sz="4000" b="1" dirty="0">
-                <a:solidFill>
-                  <a:srgbClr val="8A93A6"/>
-                </a:solidFill>
-              </a:rPr>
-              <a:t>prix     </a:t>
+              <a:rPr lang="en-US" sz="3700" b="1" dirty="0">
+                <a:solidFill>
+                  <a:srgbClr val="1B2238"/>
+                </a:solidFill>
+              </a:rPr>
+              <a:t>Samsung     </a:t>
             </a:r>
             <a:pPr algn="ctr" indent="0" marL="0">
               <a:lnSpc>
@@ -13558,12 +13660,12 @@
               <a:buNone/>
             </a:pPr>
             <a:r>
-              <a:rPr lang="en-US" sz="2800" b="1" dirty="0">
-                <a:solidFill>
-                  <a:srgbClr val="E8601C"/>
-                </a:solidFill>
-              </a:rPr>
-              <a:t>enceinte     </a:t>
+              <a:rPr lang="en-US" sz="4000" b="1" dirty="0">
+                <a:solidFill>
+                  <a:srgbClr val="8A93A6"/>
+                </a:solidFill>
+              </a:rPr>
+              <a:t>prix     </a:t>
             </a:r>
             <a:pPr algn="ctr" indent="0" marL="0">
               <a:lnSpc>
@@ -13572,16 +13674,13 @@
               <a:buNone/>
             </a:pPr>
             <a:r>
-              <a:rPr lang="en-US" sz="2400" b="1" dirty="0">
-                <a:solidFill>
-                  <a:srgbClr val="1B2238"/>
-                </a:solidFill>
-              </a:rPr>
-              <a:t>équipement enfant</a:t>
-            </a:r>
-            <a:endParaRPr lang="en-US" sz="2500" dirty="0"/>
-          </a:p>
-          <a:p>
+              <a:rPr lang="en-US" sz="2800" b="1" dirty="0">
+                <a:solidFill>
+                  <a:srgbClr val="E8601C"/>
+                </a:solidFill>
+              </a:rPr>
+              <a:t>enceinte     </a:t>
+            </a:r>
             <a:pPr algn="ctr" indent="0" marL="0">
               <a:lnSpc>
                 <a:spcPct val="105000"/>
@@ -13589,13 +13688,16 @@
               <a:buNone/>
             </a:pPr>
             <a:r>
-              <a:rPr lang="en-US" sz="2700" b="1" dirty="0">
-                <a:solidFill>
-                  <a:srgbClr val="8A93A6"/>
-                </a:solidFill>
-              </a:rPr>
-              <a:t>rendu sonore     </a:t>
-            </a:r>
+              <a:rPr lang="en-US" sz="2300" b="1" dirty="0">
+                <a:solidFill>
+                  <a:srgbClr val="E8601C"/>
+                </a:solidFill>
+              </a:rPr>
+              <a:t>PC portable</a:t>
+            </a:r>
+            <a:endParaRPr lang="en-US" sz="2500" dirty="0"/>
+          </a:p>
+          <a:p>
             <a:pPr algn="ctr" indent="0" marL="0">
               <a:lnSpc>
                 <a:spcPct val="105000"/>
@@ -13605,10 +13707,10 @@
             <a:r>
               <a:rPr lang="en-US" sz="2700" b="1" dirty="0">
                 <a:solidFill>
-                  <a:srgbClr val="E8601C"/>
-                </a:solidFill>
-              </a:rPr>
-              <a:t>casque &amp; écouteurs     </a:t>
+                  <a:srgbClr val="8A93A6"/>
+                </a:solidFill>
+              </a:rPr>
+              <a:t>rendu sonore     </a:t>
             </a:r>
             <a:pPr algn="ctr" indent="0" marL="0">
               <a:lnSpc>
@@ -13617,12 +13719,12 @@
               <a:buNone/>
             </a:pPr>
             <a:r>
-              <a:rPr lang="en-US" sz="3500" b="1" dirty="0">
-                <a:solidFill>
-                  <a:srgbClr val="1B2238"/>
-                </a:solidFill>
-              </a:rPr>
-              <a:t>panne     </a:t>
+              <a:rPr lang="en-US" sz="2700" b="1" dirty="0">
+                <a:solidFill>
+                  <a:srgbClr val="E8601C"/>
+                </a:solidFill>
+              </a:rPr>
+              <a:t>casque &amp; écouteurs     </a:t>
             </a:r>
             <a:pPr algn="ctr" indent="0" marL="0">
               <a:lnSpc>
@@ -13631,16 +13733,13 @@
               <a:buNone/>
             </a:pPr>
             <a:r>
-              <a:rPr lang="en-US" sz="2400" b="1" dirty="0">
-                <a:solidFill>
-                  <a:srgbClr val="E8601C"/>
-                </a:solidFill>
-              </a:rPr>
-              <a:t>écran PC</a:t>
-            </a:r>
-            <a:endParaRPr lang="en-US" sz="2500" dirty="0"/>
-          </a:p>
-          <a:p>
+              <a:rPr lang="en-US" sz="2700" b="1" dirty="0">
+                <a:solidFill>
+                  <a:srgbClr val="1B2238"/>
+                </a:solidFill>
+              </a:rPr>
+              <a:t>Xiaomi     </a:t>
+            </a:r>
             <a:pPr algn="ctr" indent="0" marL="0">
               <a:lnSpc>
                 <a:spcPct val="105000"/>
@@ -13648,13 +13747,16 @@
               <a:buNone/>
             </a:pPr>
             <a:r>
-              <a:rPr lang="en-US" sz="2000" b="1" dirty="0">
+              <a:rPr lang="en-US" sz="2400" b="1" dirty="0">
                 <a:solidFill>
                   <a:srgbClr val="E8601C"/>
                 </a:solidFill>
               </a:rPr>
-              <a:t>tablette     </a:t>
-            </a:r>
+              <a:t>écran PC</a:t>
+            </a:r>
+            <a:endParaRPr lang="en-US" sz="2500" dirty="0"/>
+          </a:p>
+          <a:p>
             <a:pPr algn="ctr" indent="0" marL="0">
               <a:lnSpc>
                 <a:spcPct val="105000"/>
@@ -13662,12 +13764,12 @@
               <a:buNone/>
             </a:pPr>
             <a:r>
-              <a:rPr lang="en-US" sz="1900" b="1" dirty="0">
+              <a:rPr lang="en-US" sz="2000" b="1" dirty="0">
                 <a:solidFill>
                   <a:srgbClr val="E8601C"/>
                 </a:solidFill>
               </a:rPr>
-              <a:t>téléviseur     </a:t>
+              <a:t>tablette     </a:t>
             </a:r>
             <a:pPr algn="ctr" indent="0" marL="0">
               <a:lnSpc>
@@ -13676,12 +13778,12 @@
               <a:buNone/>
             </a:pPr>
             <a:r>
-              <a:rPr lang="en-US" sz="1900" b="1" dirty="0">
+              <a:rPr lang="en-US" sz="2500" b="1" dirty="0">
                 <a:solidFill>
                   <a:srgbClr val="1B2238"/>
                 </a:solidFill>
               </a:rPr>
-              <a:t>cadeau     </a:t>
+              <a:t>Google     </a:t>
             </a:r>
             <a:pPr algn="ctr" indent="0" marL="0">
               <a:lnSpc>
@@ -13690,12 +13792,12 @@
               <a:buNone/>
             </a:pPr>
             <a:r>
-              <a:rPr lang="en-US" sz="2300" b="1" dirty="0">
+              <a:rPr lang="en-US" sz="1900" b="1" dirty="0">
                 <a:solidFill>
                   <a:srgbClr val="E8601C"/>
                 </a:solidFill>
               </a:rPr>
-              <a:t>PC portable     </a:t>
+              <a:t>téléviseur     </a:t>
             </a:r>
             <a:pPr algn="ctr" indent="0" marL="0">
               <a:lnSpc>
@@ -13709,11 +13811,8 @@
                   <a:srgbClr val="8A93A6"/>
                 </a:solidFill>
               </a:rPr>
-              <a:t>autonomie</a:t>
-            </a:r>
-            <a:endParaRPr lang="en-US" sz="2500" dirty="0"/>
-          </a:p>
-          <a:p>
+              <a:t>autonomie     </a:t>
+            </a:r>
             <a:pPr algn="ctr" indent="0" marL="0">
               <a:lnSpc>
                 <a:spcPct val="105000"/>
@@ -13723,11 +13822,14 @@
             <a:r>
               <a:rPr lang="en-US" sz="1800" b="1" dirty="0">
                 <a:solidFill>
-                  <a:srgbClr val="8A93A6"/>
-                </a:solidFill>
-              </a:rPr>
-              <a:t>qualité photo     </a:t>
-            </a:r>
+                  <a:srgbClr val="1B2238"/>
+                </a:solidFill>
+              </a:rPr>
+              <a:t>JBL</a:t>
+            </a:r>
+            <a:endParaRPr lang="en-US" sz="2500" dirty="0"/>
+          </a:p>
+          <a:p>
             <a:pPr algn="ctr" indent="0" marL="0">
               <a:lnSpc>
                 <a:spcPct val="105000"/>
@@ -13735,12 +13837,12 @@
               <a:buNone/>
             </a:pPr>
             <a:r>
-              <a:rPr lang="en-US" sz="2200" b="1" dirty="0">
-                <a:solidFill>
-                  <a:srgbClr val="1B2238"/>
-                </a:solidFill>
-              </a:rPr>
-              <a:t>étudiant     </a:t>
+              <a:rPr lang="en-US" sz="1800" b="1" dirty="0">
+                <a:solidFill>
+                  <a:srgbClr val="8A93A6"/>
+                </a:solidFill>
+              </a:rPr>
+              <a:t>qualité photo     </a:t>
             </a:r>
             <a:pPr algn="ctr" indent="0" marL="0">
               <a:lnSpc>
@@ -13749,12 +13851,12 @@
               <a:buNone/>
             </a:pPr>
             <a:r>
-              <a:rPr lang="en-US" sz="1800" b="1" dirty="0">
-                <a:solidFill>
-                  <a:srgbClr val="E8601C"/>
-                </a:solidFill>
-              </a:rPr>
-              <a:t>lave-linge     </a:t>
+              <a:rPr lang="en-US" sz="2100" b="1" dirty="0">
+                <a:solidFill>
+                  <a:srgbClr val="1B2238"/>
+                </a:solidFill>
+              </a:rPr>
+              <a:t>Sony     </a:t>
             </a:r>
             <a:pPr algn="ctr" indent="0" marL="0">
               <a:lnSpc>
@@ -13765,10 +13867,10 @@
             <a:r>
               <a:rPr lang="en-US" sz="1800" b="1" dirty="0">
                 <a:solidFill>
-                  <a:srgbClr val="1B2238"/>
-                </a:solidFill>
-              </a:rPr>
-              <a:t>séparation     </a:t>
+                  <a:srgbClr val="E8601C"/>
+                </a:solidFill>
+              </a:rPr>
+              <a:t>lave-linge     </a:t>
             </a:r>
             <a:pPr algn="ctr" indent="0" marL="0">
               <a:lnSpc>
@@ -13840,7 +13942,7 @@
                   <a:srgbClr val="1B2238"/>
                 </a:solidFill>
               </a:rPr>
-              <a:t>● Occasions   </a:t>
+              <a:t>● Marques   </a:t>
             </a:r>
             <a:pPr algn="ctr" indent="0" marL="0">
               <a:buNone/>
@@ -13925,7 +14027,7 @@
                   <a:srgbClr val="1B2238"/>
                 </a:solidFill>
               </a:rPr>
-              <a:t>le prix est le premier critère d'achat ; le smartphone, la première demande produit ; vacances et panne, les premiers déclencheurs.</a:t>
+              <a:t>le smartphone est la première demande produit, Apple et Samsung les marques les plus nommées, et le prix le premier critère d'achat.</a:t>
             </a:r>
             <a:endParaRPr lang="en-US" sz="1400" dirty="0"/>
           </a:p>

</xml_diff>